<commit_message>
[shared] retours de Romain : vocabulaire, Cosignataire dès Standard, point mort 10 clients, deck corrigé
</commit_message>
<xml_diff>
--- a/shared/pitch/Breaker-pitch.pptx
+++ b/shared/pitch/Breaker-pitch.pptx
@@ -615,7 +615,22 @@
           <a:lstStyle/>
           <a:p>
             <a:r>
-              <a:t>TIMÉO présente le playbook ; les seuils sont ceux de ia-1/score/regles.py (SEUIL_STEP_UP 0,30 ; SEUIL_HOLD 0,75).</a:t>
+              <a:t>TIMÉO.</a:t>
+            </a:r>
+          </a:p>
+          <a:p>
+            <a:r>
+              <a:t>Ce qui diffère vraiment : la signature en plus ajoute une PERSONNE ; la mise en attente ajoute du TEMPS. Une personne de plus ne sert à rien si les attaquants tiennent déjà assez de clés (Bybit) : là, seul le délai protège, parce qu'il laisse le temps de vérifier, d'annuler, de révoquer sa clé avec la clé d'identité, et parce que l'oracle et le traçage tournent pendant ce temps.</a:t>
+            </a:r>
+          </a:p>
+          <a:p>
+            <a:r>
+              <a:t>Où interviennent les agents : partout pour regarder et expliquer (automatique, toujours). Pour DÉCIDER, seulement si le client a activé le mode Cosignataire : l'agent devient un signataire qui peut refuser. En mode Protection, l'agent ne signe jamais et ne refuse jamais : il ajoute une signature à obtenir ou un délai.</a:t>
+            </a:r>
+          </a:p>
+          <a:p>
+            <a:r>
+              <a:t>Seuils : ia-1/score/regles.py (SEUIL_STEP_UP 0,30 ; SEUIL_HOLD 0,75). Niveau « Aucun » (bénéficiaire connu, montant habituel) : journalisé avec score et raisons, signatures normales.</a:t>
             </a:r>
           </a:p>
         </p:txBody>
@@ -1033,7 +1048,7 @@
           </a:p>
           <a:p>
             <a:r>
-              <a:t>Trois : elle freine. Une signature de plus, ou une attente. Jamais un blocage définitif : l'unanimité de vos signataires lève tout.</a:t>
+              <a:t>Trois : elle freine. Une signature de plus, ou une mise en attente : un délai pendant lequel rien ne part, même avec toutes les signatures. Jamais un blocage définitif : l'unanimité de vos signataires lève tout. Et si vous voulez qu'elle puisse dire non, vous activez le mode Cosignataire : un agent prend un siège de signataire et refuse de signer un paiement à risque ; vos signataires gardent une dérogation après délai.</a:t>
             </a:r>
           </a:p>
           <a:p>
@@ -1129,7 +1144,7 @@
           </a:p>
           <a:p>
             <a:r>
-              <a:t>« Les chiffres, mesurés une seule fois sur un jeu de fraudes que Romain a préparé à l'aveugle : 95 % des fraudes freinées ou arrêtées, 91 % des montants frauduleux mis en attente, 5,1 % de paiements légitimes retardés, tous de gros premiers paiements. Sur Fuji : 280 500 tentés, zéro sorti, signalement en 5 secondes, 0,002 dollar de gas par alerte. L'oracle Web : 100 % sur 35 adresses, 7 injections déjouées. Le contrat : zéro détection grave à l'analyse statique, 50 tests, 7 000 appels aléatoires sans qu'une seule promesse soit violée. »</a:t>
+              <a:t>« Les chiffres, mesurés une seule fois sur un jeu de fraudes que Romain a préparé à l'aveugle : 95 % des fraudes freinées ou mises en attente, 91 % des montants frauduleux mis en attente, 5,1 % de paiements légitimes retardés, tous de gros premiers paiements à un nouveau bénéficiaire, zéro sur les prestataires habituels. Sur Fuji : 280 500 tentés, zéro sorti, signalement en 5 secondes, 0,002 dollar de gas par alerte. L'oracle Web : 100 % sur 35 adresses, 7 injections déjouées. Le contrat : zéro détection grave à l'analyse statique, 50 tests, 7 000 appels aléatoires sans qu'une seule promesse soit violée. »</a:t>
             </a:r>
           </a:p>
           <a:p/>
@@ -1231,7 +1246,38 @@
           </a:p>
           <a:p>
             <a:r>
-              <a:t>449 euros, c'est 5 % de la perte annuelle que vous évitez, calculée avec les taux d'incidents de TRM et notre efficacité mesurée. »</a:t>
+              <a:t>449 euros, c'est 5 % de la perte annuelle que vous évitez, calculée avec les taux d'incidents de TRM et notre efficacité mesurée. Et le mode Cosignataire, l'agent qui peut dire non, est disponible dès cette formule : c'est vous qui choisissez le pouvoir que vous lui déléguez. »</a:t>
+            </a:r>
+          </a:p>
+          <a:p/>
+          <a:p>
+            <a:r>
+              <a:t>LE CALCUL DE LA PERTE ANNUELLE ÉVITÉE, si on nous le demande (tout est dans shared/business-prix.md § 1.B) :</a:t>
+            </a:r>
+          </a:p>
+          <a:p>
+            <a:r>
+              <a:t>• Probabilité d'un incident dans l'année ≈ 9,5 % : TRM Labs compte ≈ 150 incidents significatifs en 2025 ; on les rapporte à la population des organisations qui ont au moins 1 M$ : 1 359 protocoles avec plus de 1 M$ d'actifs (API DeFiLlama) + 220 DAO avec plus de 1 M$ de trésorerie (DeepDAO) = 1 579. 150 / 1 579 = 9,5 %. C'est une borne haute : tous ces incidents ne sont pas des fraudes de signataires ; on montre aussi le cas où un incident sur cinq est dans notre périmètre.</a:t>
+            </a:r>
+          </a:p>
+          <a:p>
+            <a:r>
+              <a:t>• Perte médiane par incident = 1,3 M$ : médiane des incidents significatifs de 2025 selon TRM Labs (la moitié des incidents coûtent plus, la moitié moins). Deux autres sources l'encadrent : Immunefi donne 1,5 M$ de médiane en DeFi ; CertiK donne 104 k$ mais sur un périmètre beaucoup plus large qui inclut les petits incidents (plus de 700). On prend TRM parce que son périmètre (incidents significatifs) ressemble au nôtre.</a:t>
+            </a:r>
+          </a:p>
+          <a:p>
+            <a:r>
+              <a:t>• Efficacité = 91 % : part des montants frauduleux que Breaker a mis en attente sur le jeu final, préparé à l'aveugle (shared/mesures.md).</a:t>
+            </a:r>
+          </a:p>
+          <a:p>
+            <a:r>
+              <a:t>• Perte évitée = 9,5 % × 1,3 M$ × 91 % ≈ 112 k$ par an ; 22 k$ si un incident sur cinq est dans notre périmètre.</a:t>
+            </a:r>
+          </a:p>
+          <a:p>
+            <a:r>
+              <a:t>• Règle de prix : un outil de sécurité se vend sans discussion sous 10 % de la perte qu'il évite ; 449 € × 12 = 5 400 € = 5 % de 112 k$ (25 % de 22 k$).</a:t>
             </a:r>
           </a:p>
           <a:p/>
@@ -1312,7 +1358,13 @@
           </a:p>
           <a:p>
             <a:r>
-              <a:t>« Première année : 62 organisations présentées par l'écosystème Avalanche, la moitié en observation, 3 à 6 clients payants selon les taux de conversion du SaaS B2B. L'audit externe avant le premier euro. Puis le même code sur les autres chaînes compatibles : point mort à 17 clients, entre fin 2027 et mi-2028, plus tôt avec un seul client Premium. »</a:t>
+              <a:t>« Première année : 62 organisations présentées par l'écosystème Avalanche, la moitié en observation, 3 à 6 clients payants selon les taux de conversion du SaaS B2B. L'audit externe avant le premier euro. Puis le même code sur les autres chaînes compatibles. Nos coûts fixes sont de 4 300 euros par mois, deux fondateurs à 2 000 euros : le point mort est à 10 clients Standard, atteignable entre le troisième trimestre 2027 et la mi-2028 selon le taux de conversion, plus tôt avec un seul client Premium. »</a:t>
+            </a:r>
+          </a:p>
+          <a:p/>
+          <a:p>
+            <a:r>
+              <a:t>Si on demande « comment vous arrivez à 10 clients ? » : à l'envers. 10 clients ÷ 8,9 à 18,5 % de conversion = 54 à 112 équipes en observation ÷ une sur deux qui accepte = 108 à 225 équipes à contacter. Avalanche en donne 62 d'ici décembre ; chaque nouvel écosystème EVM en donne autant par semestre : un à trois écosystèmes de plus, donc T3 2027 dans le cas favorable, mi-2028 dans le cas défavorable.</a:t>
             </a:r>
           </a:p>
           <a:p/>
@@ -5798,7 +5850,7 @@
                 </a:solidFill>
                 <a:latin typeface="Manrope"/>
               </a:rPr>
-              <a:t>Automatique : regarder, expliquer, freiner. Humain : décider, toujours.</a:t>
+              <a:t>Trois réponses graduées : une paire d'yeux en plus, du temps, un refus.</a:t>
             </a:r>
           </a:p>
         </p:txBody>
@@ -5811,8 +5863,8 @@
         </p:nvSpPr>
         <p:spPr>
           <a:xfrm>
-            <a:off x="731520" y="2167128"/>
-            <a:ext cx="1600200" cy="713232"/>
+            <a:off x="731520" y="2121408"/>
+            <a:ext cx="1463040" cy="822960"/>
           </a:xfrm>
           <a:prstGeom prst="rect">
             <a:avLst/>
@@ -5850,8 +5902,8 @@
         </p:nvSpPr>
         <p:spPr>
           <a:xfrm>
-            <a:off x="2468880" y="2167128"/>
-            <a:ext cx="2331720" cy="713232"/>
+            <a:off x="2331720" y="2121408"/>
+            <a:ext cx="1965960" cy="822960"/>
           </a:xfrm>
           <a:prstGeom prst="rect">
             <a:avLst/>
@@ -5889,8 +5941,8 @@
         </p:nvSpPr>
         <p:spPr>
           <a:xfrm>
-            <a:off x="4937760" y="2167128"/>
-            <a:ext cx="2514600" cy="713232"/>
+            <a:off x="4434840" y="2121408"/>
+            <a:ext cx="2880360" cy="822960"/>
           </a:xfrm>
           <a:prstGeom prst="rect">
             <a:avLst/>
@@ -5915,7 +5967,7 @@
                 </a:solidFill>
                 <a:latin typeface="DM Sans"/>
               </a:rPr>
-              <a:t>Automatique</a:t>
+              <a:t>Ce qui se passe, automatiquement</a:t>
             </a:r>
           </a:p>
         </p:txBody>
@@ -5928,8 +5980,8 @@
         </p:nvSpPr>
         <p:spPr>
           <a:xfrm>
-            <a:off x="7589520" y="2167128"/>
-            <a:ext cx="2057400" cy="713232"/>
+            <a:off x="7452360" y="2121408"/>
+            <a:ext cx="2240280" cy="822960"/>
           </a:xfrm>
           <a:prstGeom prst="rect">
             <a:avLst/>
@@ -5954,46 +6006,46 @@
                 </a:solidFill>
                 <a:latin typeface="DM Sans"/>
               </a:rPr>
+              <a:t>Ce que ça protège vraiment</a:t>
+            </a:r>
+          </a:p>
+        </p:txBody>
+      </p:sp>
+      <p:sp>
+        <p:nvSpPr>
+          <p:cNvPr id="17" name="TextBox 16"/>
+          <p:cNvSpPr txBox="1"/>
+          <p:nvPr/>
+        </p:nvSpPr>
+        <p:spPr>
+          <a:xfrm>
+            <a:off x="9829800" y="2121408"/>
+            <a:ext cx="1493215" cy="822960"/>
+          </a:xfrm>
+          <a:prstGeom prst="rect">
+            <a:avLst/>
+          </a:prstGeom>
+          <a:noFill/>
+        </p:spPr>
+        <p:txBody>
+          <a:bodyPr wrap="square" anchor="t" lIns="0" rIns="0" tIns="0" bIns="0">
+            <a:spAutoFit/>
+          </a:bodyPr>
+          <a:lstStyle/>
+          <a:p>
+            <a:pPr algn="l">
+              <a:lnSpc>
+                <a:spcPct val="105000"/>
+              </a:lnSpc>
+            </a:pPr>
+            <a:r>
+              <a:rPr sz="1000" b="0">
+                <a:solidFill>
+                  <a:srgbClr val="7F8B9B"/>
+                </a:solidFill>
+                <a:latin typeface="DM Sans"/>
+              </a:rPr>
               <a:t>Humain</a:t>
-            </a:r>
-          </a:p>
-        </p:txBody>
-      </p:sp>
-      <p:sp>
-        <p:nvSpPr>
-          <p:cNvPr id="17" name="TextBox 16"/>
-          <p:cNvSpPr txBox="1"/>
-          <p:nvPr/>
-        </p:nvSpPr>
-        <p:spPr>
-          <a:xfrm>
-            <a:off x="9784080" y="2167128"/>
-            <a:ext cx="1538935" cy="713232"/>
-          </a:xfrm>
-          <a:prstGeom prst="rect">
-            <a:avLst/>
-          </a:prstGeom>
-          <a:noFill/>
-        </p:spPr>
-        <p:txBody>
-          <a:bodyPr wrap="square" anchor="t" lIns="0" rIns="0" tIns="0" bIns="0">
-            <a:spAutoFit/>
-          </a:bodyPr>
-          <a:lstStyle/>
-          <a:p>
-            <a:pPr algn="l">
-              <a:lnSpc>
-                <a:spcPct val="105000"/>
-              </a:lnSpc>
-            </a:pPr>
-            <a:r>
-              <a:rPr sz="1000" b="0">
-                <a:solidFill>
-                  <a:srgbClr val="7F8B9B"/>
-                </a:solidFill>
-                <a:latin typeface="DM Sans"/>
-              </a:rPr>
-              <a:t>Alerté</a:t>
             </a:r>
           </a:p>
         </p:txBody>
@@ -6006,7 +6058,7 @@
         </p:nvSpPr>
         <p:spPr>
           <a:xfrm>
-            <a:off x="731520" y="2810352"/>
+            <a:off x="731520" y="2874360"/>
             <a:ext cx="10728655" cy="6000"/>
           </a:xfrm>
           <a:prstGeom prst="rect">
@@ -6050,8 +6102,8 @@
         </p:nvSpPr>
         <p:spPr>
           <a:xfrm>
-            <a:off x="731520" y="2880360"/>
-            <a:ext cx="1600200" cy="713232"/>
+            <a:off x="731520" y="2944368"/>
+            <a:ext cx="1463040" cy="822960"/>
           </a:xfrm>
           <a:prstGeom prst="rect">
             <a:avLst/>
@@ -6070,13 +6122,13 @@
               </a:lnSpc>
             </a:pPr>
             <a:r>
-              <a:rPr sz="1050" b="1">
+              <a:rPr sz="1000" b="1">
                 <a:solidFill>
                   <a:srgbClr val="F6F9FC"/>
                 </a:solidFill>
                 <a:latin typeface="DM Sans"/>
               </a:rPr>
-              <a:t>Aucun</a:t>
+              <a:t>Signature en plus (score ≥ 0,30)</a:t>
             </a:r>
           </a:p>
         </p:txBody>
@@ -6089,8 +6141,8 @@
         </p:nvSpPr>
         <p:spPr>
           <a:xfrm>
-            <a:off x="2468880" y="2880360"/>
-            <a:ext cx="2331720" cy="713232"/>
+            <a:off x="2331720" y="2944368"/>
+            <a:ext cx="1965960" cy="822960"/>
           </a:xfrm>
           <a:prstGeom prst="rect">
             <a:avLst/>
@@ -6109,13 +6161,13 @@
               </a:lnSpc>
             </a:pPr>
             <a:r>
-              <a:rPr sz="1050" b="0">
+              <a:rPr sz="1000" b="0">
                 <a:solidFill>
                   <a:srgbClr val="E7EDF4"/>
                 </a:solidFill>
                 <a:latin typeface="DM Sans"/>
               </a:rPr>
-              <a:t>bénéficiaire connu, montant habituel</a:t>
+              <a:t>nouveau bénéficiaire, montant inhabituel, « urgent », hors heures</a:t>
             </a:r>
           </a:p>
         </p:txBody>
@@ -6128,8 +6180,8 @@
         </p:nvSpPr>
         <p:spPr>
           <a:xfrm>
-            <a:off x="4937760" y="2880360"/>
-            <a:ext cx="2514600" cy="713232"/>
+            <a:off x="4434840" y="2944368"/>
+            <a:ext cx="2880360" cy="822960"/>
           </a:xfrm>
           <a:prstGeom prst="rect">
             <a:avLst/>
@@ -6148,13 +6200,13 @@
               </a:lnSpc>
             </a:pPr>
             <a:r>
-              <a:rPr sz="1050" b="0">
+              <a:rPr sz="1000" b="0">
                 <a:solidFill>
                   <a:srgbClr val="E7EDF4"/>
                 </a:solidFill>
                 <a:latin typeface="DM Sans"/>
               </a:rPr>
-              <a:t>journalisé : score et raisons</a:t>
+              <a:t>le paiement exige une signature humaine de plus que votre seuil ; explication en français à tous les signataires</a:t>
             </a:r>
           </a:p>
         </p:txBody>
@@ -6167,8 +6219,8 @@
         </p:nvSpPr>
         <p:spPr>
           <a:xfrm>
-            <a:off x="7589520" y="2880360"/>
-            <a:ext cx="2057400" cy="713232"/>
+            <a:off x="7452360" y="2944368"/>
+            <a:ext cx="2240280" cy="822960"/>
           </a:xfrm>
           <a:prstGeom prst="rect">
             <a:avLst/>
@@ -6187,13 +6239,13 @@
               </a:lnSpc>
             </a:pPr>
             <a:r>
-              <a:rPr sz="1050" b="0">
+              <a:rPr sz="1000" b="0">
                 <a:solidFill>
                   <a:srgbClr val="E7EDF4"/>
                 </a:solidFill>
                 <a:latin typeface="DM Sans"/>
               </a:rPr>
-              <a:t>signatures normales</a:t>
+              <a:t>contre UN signataire trompé ou une clé volée quand le quorum vient d'être atteint : une autre personne relit</a:t>
             </a:r>
           </a:p>
         </p:txBody>
@@ -6206,8 +6258,8 @@
         </p:nvSpPr>
         <p:spPr>
           <a:xfrm>
-            <a:off x="9784080" y="2880360"/>
-            <a:ext cx="1538935" cy="713232"/>
+            <a:off x="9829800" y="2944368"/>
+            <a:ext cx="1493215" cy="822960"/>
           </a:xfrm>
           <a:prstGeom prst="rect">
             <a:avLst/>
@@ -6226,13 +6278,13 @@
               </a:lnSpc>
             </a:pPr>
             <a:r>
-              <a:rPr sz="1050" b="0">
+              <a:rPr sz="1000" b="0">
                 <a:solidFill>
                   <a:srgbClr val="E7EDF4"/>
                 </a:solidFill>
                 <a:latin typeface="DM Sans"/>
               </a:rPr>
-              <a:t>—</a:t>
+              <a:t>un signataire de plus relit « ce que vous signez » et signe, ou non</a:t>
             </a:r>
           </a:p>
         </p:txBody>
@@ -6245,7 +6297,7 @@
         </p:nvSpPr>
         <p:spPr>
           <a:xfrm>
-            <a:off x="731520" y="3523584"/>
+            <a:off x="731520" y="3697320"/>
             <a:ext cx="10728655" cy="6000"/>
           </a:xfrm>
           <a:prstGeom prst="rect">
@@ -6289,8 +6341,8 @@
         </p:nvSpPr>
         <p:spPr>
           <a:xfrm>
-            <a:off x="731520" y="3593592"/>
-            <a:ext cx="1600200" cy="713232"/>
+            <a:off x="731520" y="3767328"/>
+            <a:ext cx="1463040" cy="822960"/>
           </a:xfrm>
           <a:prstGeom prst="rect">
             <a:avLst/>
@@ -6309,13 +6361,13 @@
               </a:lnSpc>
             </a:pPr>
             <a:r>
-              <a:rPr sz="1050" b="1">
+              <a:rPr sz="1000" b="1">
                 <a:solidFill>
                   <a:srgbClr val="F6F9FC"/>
                 </a:solidFill>
                 <a:latin typeface="DM Sans"/>
               </a:rPr>
-              <a:t>Signature en plus (≥ 0,30)</a:t>
+              <a:t>Mise en attente (score ≥ 0,75)</a:t>
             </a:r>
           </a:p>
         </p:txBody>
@@ -6328,8 +6380,8 @@
         </p:nvSpPr>
         <p:spPr>
           <a:xfrm>
-            <a:off x="2468880" y="3593592"/>
-            <a:ext cx="2331720" cy="713232"/>
+            <a:off x="2331720" y="3767328"/>
+            <a:ext cx="1965960" cy="822960"/>
           </a:xfrm>
           <a:prstGeom prst="rect">
             <a:avLst/>
@@ -6348,13 +6400,13 @@
               </a:lnSpc>
             </a:pPr>
             <a:r>
-              <a:rPr sz="1050" b="0">
+              <a:rPr sz="1000" b="0">
                 <a:solidFill>
                   <a:srgbClr val="E7EDF4"/>
                 </a:solidFill>
                 <a:latin typeface="DM Sans"/>
               </a:rPr>
-              <a:t>nouveau bénéficiaire, montant inhabituel, « urgent », hors heures</a:t>
+              <a:t>rafale, adresse signalée, fonds souillés, sosie, nouveau signataire qui pousse un gros paiement</a:t>
             </a:r>
           </a:p>
         </p:txBody>
@@ -6367,8 +6419,8 @@
         </p:nvSpPr>
         <p:spPr>
           <a:xfrm>
-            <a:off x="4937760" y="3593592"/>
-            <a:ext cx="2514600" cy="713232"/>
+            <a:off x="4434840" y="3767328"/>
+            <a:ext cx="2880360" cy="822960"/>
           </a:xfrm>
           <a:prstGeom prst="rect">
             <a:avLst/>
@@ -6387,13 +6439,13 @@
               </a:lnSpc>
             </a:pPr>
             <a:r>
-              <a:rPr sz="1050" b="0">
+              <a:rPr sz="1000" b="0">
                 <a:solidFill>
                   <a:srgbClr val="E7EDF4"/>
                 </a:solidFill>
                 <a:latin typeface="DM Sans"/>
               </a:rPr>
-              <a:t>exige une signature de plus ; explication en français</a:t>
+              <a:t>signature en plus ET un délai (24 h en réel, 180 s en démo) pendant lequel rien ne part, même avec toutes les signatures ; oracle, traçage et rapport d'incident tournent pendant ce temps</a:t>
             </a:r>
           </a:p>
         </p:txBody>
@@ -6406,8 +6458,8 @@
         </p:nvSpPr>
         <p:spPr>
           <a:xfrm>
-            <a:off x="7589520" y="3593592"/>
-            <a:ext cx="2057400" cy="713232"/>
+            <a:off x="7452360" y="3767328"/>
+            <a:ext cx="2240280" cy="822960"/>
           </a:xfrm>
           <a:prstGeom prst="rect">
             <a:avLst/>
@@ -6426,13 +6478,13 @@
               </a:lnSpc>
             </a:pPr>
             <a:r>
-              <a:rPr sz="1050" b="0">
+              <a:rPr sz="1000" b="0">
                 <a:solidFill>
                   <a:srgbClr val="E7EDF4"/>
                 </a:solidFill>
                 <a:latin typeface="DM Sans"/>
               </a:rPr>
-              <a:t>un signataire supplémentaire relit « ce que vous signez »</a:t>
+              <a:t>contre des attaquants qui tiennent DÉJÀ assez de clés (Bybit : 3 sur 6) : la seule protection qui reste est le temps, pour vérifier, annuler, ou révoquer sa clé</a:t>
             </a:r>
           </a:p>
         </p:txBody>
@@ -6445,8 +6497,8 @@
         </p:nvSpPr>
         <p:spPr>
           <a:xfrm>
-            <a:off x="9784080" y="3593592"/>
-            <a:ext cx="1538935" cy="713232"/>
+            <a:off x="9829800" y="3767328"/>
+            <a:ext cx="1493215" cy="822960"/>
           </a:xfrm>
           <a:prstGeom prst="rect">
             <a:avLst/>
@@ -6465,13 +6517,13 @@
               </a:lnSpc>
             </a:pPr>
             <a:r>
-              <a:rPr sz="1050" b="0">
+              <a:rPr sz="1000" b="0">
                 <a:solidFill>
                   <a:srgbClr val="E7EDF4"/>
                 </a:solidFill>
                 <a:latin typeface="DM Sans"/>
               </a:rPr>
-              <a:t>tous les signataires (tableau de bord, e-mail / Telegram)</a:t>
+              <a:t>vérifier, annuler, ou lever l'attente à l'unanimité ; juger vraie / fausse alerte</a:t>
             </a:r>
           </a:p>
         </p:txBody>
@@ -6484,7 +6536,7 @@
         </p:nvSpPr>
         <p:spPr>
           <a:xfrm>
-            <a:off x="731520" y="4236816"/>
+            <a:off x="731520" y="4520280"/>
             <a:ext cx="10728655" cy="6000"/>
           </a:xfrm>
           <a:prstGeom prst="rect">
@@ -6528,8 +6580,8 @@
         </p:nvSpPr>
         <p:spPr>
           <a:xfrm>
-            <a:off x="731520" y="4306824"/>
-            <a:ext cx="1600200" cy="713232"/>
+            <a:off x="731520" y="4590288"/>
+            <a:ext cx="1463040" cy="822960"/>
           </a:xfrm>
           <a:prstGeom prst="rect">
             <a:avLst/>
@@ -6548,13 +6600,13 @@
               </a:lnSpc>
             </a:pPr>
             <a:r>
-              <a:rPr sz="1050" b="1">
+              <a:rPr sz="1000" b="1">
                 <a:solidFill>
                   <a:srgbClr val="F6F9FC"/>
                 </a:solidFill>
                 <a:latin typeface="DM Sans"/>
               </a:rPr>
-              <a:t>Mise en attente (≥ 0,75)</a:t>
+              <a:t>Cosignataire (option, dès Standard)</a:t>
             </a:r>
           </a:p>
         </p:txBody>
@@ -6567,8 +6619,8 @@
         </p:nvSpPr>
         <p:spPr>
           <a:xfrm>
-            <a:off x="2468880" y="4306824"/>
-            <a:ext cx="2331720" cy="713232"/>
+            <a:off x="2331720" y="4590288"/>
+            <a:ext cx="1965960" cy="822960"/>
           </a:xfrm>
           <a:prstGeom prst="rect">
             <a:avLst/>
@@ -6587,13 +6639,13 @@
               </a:lnSpc>
             </a:pPr>
             <a:r>
-              <a:rPr sz="1050" b="0">
+              <a:rPr sz="1000" b="0">
                 <a:solidFill>
                   <a:srgbClr val="E7EDF4"/>
                 </a:solidFill>
                 <a:latin typeface="DM Sans"/>
               </a:rPr>
-              <a:t>rafale, adresse signalée, fonds souillés, sosie, nouveau signataire qui pousse un gros paiement</a:t>
+              <a:t>mêmes signaux ; le client a activé le mode</a:t>
             </a:r>
           </a:p>
         </p:txBody>
@@ -6606,8 +6658,8 @@
         </p:nvSpPr>
         <p:spPr>
           <a:xfrm>
-            <a:off x="4937760" y="4306824"/>
-            <a:ext cx="2514600" cy="713232"/>
+            <a:off x="4434840" y="4590288"/>
+            <a:ext cx="2880360" cy="822960"/>
           </a:xfrm>
           <a:prstGeom prst="rect">
             <a:avLst/>
@@ -6626,13 +6678,13 @@
               </a:lnSpc>
             </a:pPr>
             <a:r>
-              <a:rPr sz="1050" b="0">
+              <a:rPr sz="1000" b="0">
                 <a:solidFill>
                   <a:srgbClr val="E7EDF4"/>
                 </a:solidFill>
                 <a:latin typeface="DM Sans"/>
               </a:rPr>
-              <a:t>attente (180 s en démo, 24 h en réel) + signature en plus ; rapport d'incident pré-rempli</a:t>
+              <a:t>l'agent occupe un siège de signataire : il REFUSE de signer un paiement à risque, donc le quorum n'est pas atteint ; c'est le seul niveau qui bloque</a:t>
             </a:r>
           </a:p>
         </p:txBody>
@@ -6645,8 +6697,8 @@
         </p:nvSpPr>
         <p:spPr>
           <a:xfrm>
-            <a:off x="7589520" y="4306824"/>
-            <a:ext cx="2057400" cy="713232"/>
+            <a:off x="7452360" y="4590288"/>
+            <a:ext cx="2240280" cy="822960"/>
           </a:xfrm>
           <a:prstGeom prst="rect">
             <a:avLst/>
@@ -6665,13 +6717,13 @@
               </a:lnSpc>
             </a:pPr>
             <a:r>
-              <a:rPr sz="1050" b="0">
+              <a:rPr sz="1000" b="0">
                 <a:solidFill>
                   <a:srgbClr val="E7EDF4"/>
                 </a:solidFill>
                 <a:latin typeface="DM Sans"/>
               </a:rPr>
-              <a:t>vérifier, annuler, ou lever à l'unanimité ; juger vraie / fausse alerte</a:t>
+              <a:t>contre une équipe qui, sous pression, signerait quand même : le non est posé par l'agent, pas par un collègue</a:t>
             </a:r>
           </a:p>
         </p:txBody>
@@ -6684,8 +6736,8 @@
         </p:nvSpPr>
         <p:spPr>
           <a:xfrm>
-            <a:off x="9784080" y="4306824"/>
-            <a:ext cx="1538935" cy="713232"/>
+            <a:off x="9829800" y="4590288"/>
+            <a:ext cx="1493215" cy="822960"/>
           </a:xfrm>
           <a:prstGeom prst="rect">
             <a:avLst/>
@@ -6704,13 +6756,13 @@
               </a:lnSpc>
             </a:pPr>
             <a:r>
-              <a:rPr sz="1050" b="0">
+              <a:rPr sz="1000" b="0">
                 <a:solidFill>
                   <a:srgbClr val="E7EDF4"/>
                 </a:solidFill>
                 <a:latin typeface="DM Sans"/>
               </a:rPr>
-              <a:t>tous les signataires + responsable désigné</a:t>
+              <a:t>dérogation renforcée après délai : les signataires humains peuvent passer outre, à plusieurs</a:t>
             </a:r>
           </a:p>
         </p:txBody>
@@ -6723,7 +6775,7 @@
         </p:nvSpPr>
         <p:spPr>
           <a:xfrm>
-            <a:off x="731520" y="4950048"/>
+            <a:off x="731520" y="5343240"/>
             <a:ext cx="10728655" cy="6000"/>
           </a:xfrm>
           <a:prstGeom prst="rect">
@@ -6767,8 +6819,8 @@
         </p:nvSpPr>
         <p:spPr>
           <a:xfrm>
-            <a:off x="731520" y="5020056"/>
-            <a:ext cx="1600200" cy="713232"/>
+            <a:off x="731520" y="5413248"/>
+            <a:ext cx="1463040" cy="822960"/>
           </a:xfrm>
           <a:prstGeom prst="rect">
             <a:avLst/>
@@ -6787,7 +6839,7 @@
               </a:lnSpc>
             </a:pPr>
             <a:r>
-              <a:rPr sz="1050" b="1">
+              <a:rPr sz="1000" b="1">
                 <a:solidFill>
                   <a:srgbClr val="F6F9FC"/>
                 </a:solidFill>
@@ -6806,8 +6858,8 @@
         </p:nvSpPr>
         <p:spPr>
           <a:xfrm>
-            <a:off x="2468880" y="5020056"/>
-            <a:ext cx="2331720" cy="713232"/>
+            <a:off x="2331720" y="5413248"/>
+            <a:ext cx="1965960" cy="822960"/>
           </a:xfrm>
           <a:prstGeom prst="rect">
             <a:avLst/>
@@ -6826,7 +6878,7 @@
               </a:lnSpc>
             </a:pPr>
             <a:r>
-              <a:rPr sz="1050" b="0">
+              <a:rPr sz="1000" b="0">
                 <a:solidFill>
                   <a:srgbClr val="E7EDF4"/>
                 </a:solidFill>
@@ -6845,8 +6897,8 @@
         </p:nvSpPr>
         <p:spPr>
           <a:xfrm>
-            <a:off x="4937760" y="5020056"/>
-            <a:ext cx="2514600" cy="713232"/>
+            <a:off x="4434840" y="5413248"/>
+            <a:ext cx="2880360" cy="822960"/>
           </a:xfrm>
           <a:prstGeom prst="rect">
             <a:avLst/>
@@ -6865,13 +6917,13 @@
               </a:lnSpc>
             </a:pPr>
             <a:r>
-              <a:rPr sz="1050" b="0">
+              <a:rPr sz="1000" b="0">
                 <a:solidFill>
                   <a:srgbClr val="E7EDF4"/>
                 </a:solidFill>
                 <a:latin typeface="DM Sans"/>
               </a:rPr>
-              <a:t>clé d'identité : révocation immédiate par la victime seule ; clé de contrainte : gel silencieux, alerte privée</a:t>
+              <a:t>clé d'identité : révocation immédiate par la victime seule ; clé de contrainte : gel silencieux et alerte privée</a:t>
             </a:r>
           </a:p>
         </p:txBody>
@@ -6884,8 +6936,8 @@
         </p:nvSpPr>
         <p:spPr>
           <a:xfrm>
-            <a:off x="7589520" y="5020056"/>
-            <a:ext cx="2057400" cy="713232"/>
+            <a:off x="7452360" y="5413248"/>
+            <a:ext cx="2240280" cy="822960"/>
           </a:xfrm>
           <a:prstGeom prst="rect">
             <a:avLst/>
@@ -6904,13 +6956,13 @@
               </a:lnSpc>
             </a:pPr>
             <a:r>
-              <a:rPr sz="1050" b="0">
+              <a:rPr sz="1000" b="0">
                 <a:solidFill>
                   <a:srgbClr val="E7EDF4"/>
                 </a:solidFill>
                 <a:latin typeface="DM Sans"/>
               </a:rPr>
-              <a:t>remplacer la clé, dégeler à la majorité des clés saines</a:t>
+              <a:t>contre la perte d'une clé ou la menace physique sur une personne</a:t>
             </a:r>
           </a:p>
         </p:txBody>
@@ -6923,8 +6975,8 @@
         </p:nvSpPr>
         <p:spPr>
           <a:xfrm>
-            <a:off x="9784080" y="5020056"/>
-            <a:ext cx="1538935" cy="713232"/>
+            <a:off x="9829800" y="5413248"/>
+            <a:ext cx="1493215" cy="822960"/>
           </a:xfrm>
           <a:prstGeom prst="rect">
             <a:avLst/>
@@ -6943,13 +6995,13 @@
               </a:lnSpc>
             </a:pPr>
             <a:r>
-              <a:rPr sz="1050" b="0">
+              <a:rPr sz="1000" b="0">
                 <a:solidFill>
                   <a:srgbClr val="E7EDF4"/>
                 </a:solidFill>
                 <a:latin typeface="DM Sans"/>
               </a:rPr>
-              <a:t>canal privé aux autres signataires, jamais on-chain</a:t>
+              <a:t>remplacer la clé ; dégeler à la majorité des clés saines</a:t>
             </a:r>
           </a:p>
         </p:txBody>
@@ -6962,7 +7014,7 @@
         </p:nvSpPr>
         <p:spPr>
           <a:xfrm>
-            <a:off x="731520" y="5663280"/>
+            <a:off x="731520" y="6166200"/>
             <a:ext cx="10728655" cy="6000"/>
           </a:xfrm>
           <a:prstGeom prst="rect">
@@ -11156,45 +11208,6 @@
           </a:p>
         </p:txBody>
       </p:sp>
-      <p:sp>
-        <p:nvSpPr>
-          <p:cNvPr id="26" name="TextBox 25"/>
-          <p:cNvSpPr txBox="1"/>
-          <p:nvPr/>
-        </p:nvSpPr>
-        <p:spPr>
-          <a:xfrm>
-            <a:off x="731520" y="5897880"/>
-            <a:ext cx="10728655" cy="274320"/>
-          </a:xfrm>
-          <a:prstGeom prst="rect">
-            <a:avLst/>
-          </a:prstGeom>
-          <a:noFill/>
-        </p:spPr>
-        <p:txBody>
-          <a:bodyPr wrap="square" anchor="t" lIns="0" rIns="0" tIns="0" bIns="0">
-            <a:spAutoFit/>
-          </a:bodyPr>
-          <a:lstStyle/>
-          <a:p>
-            <a:pPr algn="l">
-              <a:lnSpc>
-                <a:spcPct val="115000"/>
-              </a:lnSpc>
-            </a:pPr>
-            <a:r>
-              <a:rPr sz="950" b="0">
-                <a:solidFill>
-                  <a:srgbClr val="7F8B9B"/>
-                </a:solidFill>
-                <a:latin typeface="DM Sans"/>
-              </a:rPr>
-              <a:t>shared/business-probleme.md · TRM Labs 2025 · fireblocks.com/pricing</a:t>
-            </a:r>
-          </a:p>
-        </p:txBody>
-      </p:sp>
     </p:spTree>
   </p:cSld>
   <p:clrMapOvr>
@@ -12466,45 +12479,6 @@
           </a:p>
         </p:txBody>
       </p:sp>
-      <p:sp>
-        <p:nvSpPr>
-          <p:cNvPr id="30" name="TextBox 29"/>
-          <p:cNvSpPr txBox="1"/>
-          <p:nvPr/>
-        </p:nvSpPr>
-        <p:spPr>
-          <a:xfrm>
-            <a:off x="731520" y="5897880"/>
-            <a:ext cx="10728655" cy="274320"/>
-          </a:xfrm>
-          <a:prstGeom prst="rect">
-            <a:avLst/>
-          </a:prstGeom>
-          <a:noFill/>
-        </p:spPr>
-        <p:txBody>
-          <a:bodyPr wrap="square" anchor="t" lIns="0" rIns="0" tIns="0" bIns="0">
-            <a:spAutoFit/>
-          </a:bodyPr>
-          <a:lstStyle/>
-          <a:p>
-            <a:pPr algn="l">
-              <a:lnSpc>
-                <a:spcPct val="115000"/>
-              </a:lnSpc>
-            </a:pPr>
-            <a:r>
-              <a:rPr sz="950" b="0">
-                <a:solidFill>
-                  <a:srgbClr val="7F8B9B"/>
-                </a:solidFill>
-                <a:latin typeface="DM Sans"/>
-              </a:rPr>
-              <a:t>shared/business-marche.md D1–D5 · Safe Foundation, rapport T1 2026</a:t>
-            </a:r>
-          </a:p>
-        </p:txBody>
-      </p:sp>
     </p:spTree>
   </p:cSld>
   <p:clrMapOvr>
@@ -14117,6 +14091,54 @@
         <p:spPr>
           <a:xfrm>
             <a:off x="731520" y="5349240"/>
+            <a:ext cx="10728655" cy="365760"/>
+          </a:xfrm>
+          <a:prstGeom prst="rect">
+            <a:avLst/>
+          </a:prstGeom>
+          <a:noFill/>
+        </p:spPr>
+        <p:txBody>
+          <a:bodyPr wrap="square" anchor="t" lIns="0" rIns="0" tIns="0" bIns="0">
+            <a:spAutoFit/>
+          </a:bodyPr>
+          <a:lstStyle/>
+          <a:p>
+            <a:pPr algn="l">
+              <a:lnSpc>
+                <a:spcPct val="115000"/>
+              </a:lnSpc>
+            </a:pPr>
+            <a:r>
+              <a:rPr sz="1300" b="1">
+                <a:solidFill>
+                  <a:srgbClr val="F6F9FC"/>
+                </a:solidFill>
+                <a:latin typeface="DM Sans"/>
+              </a:rPr>
+              <a:t>Et protège la personne : </a:t>
+            </a:r>
+            <a:r>
+              <a:rPr sz="1300" b="0">
+                <a:solidFill>
+                  <a:srgbClr val="A9B4C2"/>
+                </a:solidFill>
+                <a:latin typeface="DM Sans"/>
+              </a:rPr>
+              <a:t>clé d'identité pour révoquer seul sa clé volée · clé de contrainte qui dit « oui » à l'écran et gèle en silence · probation des clés neuves.</a:t>
+            </a:r>
+          </a:p>
+        </p:txBody>
+      </p:sp>
+      <p:sp>
+        <p:nvSpPr>
+          <p:cNvPr id="40" name="TextBox 39"/>
+          <p:cNvSpPr txBox="1"/>
+          <p:nvPr/>
+        </p:nvSpPr>
+        <p:spPr>
+          <a:xfrm>
+            <a:off x="731520" y="5687568"/>
             <a:ext cx="10728655" cy="457200"/>
           </a:xfrm>
           <a:prstGeom prst="rect">
@@ -14136,61 +14158,49 @@
               </a:lnSpc>
             </a:pPr>
             <a:r>
-              <a:rPr sz="1350" b="1">
+              <a:rPr sz="1300" b="1">
                 <a:solidFill>
                   <a:srgbClr val="F6F9FC"/>
                 </a:solidFill>
                 <a:latin typeface="DM Sans"/>
               </a:rPr>
-              <a:t>Et protège la personne : </a:t>
-            </a:r>
-            <a:r>
-              <a:rPr sz="1350" b="0">
+              <a:t>Deux modes, au choix du client : </a:t>
+            </a:r>
+            <a:r>
+              <a:rPr sz="1300" b="1">
+                <a:solidFill>
+                  <a:srgbClr val="C7FA70"/>
+                </a:solidFill>
+                <a:latin typeface="DM Sans"/>
+              </a:rPr>
+              <a:t>Protection</a:t>
+            </a:r>
+            <a:r>
+              <a:rPr sz="1300" b="0">
                 <a:solidFill>
                   <a:srgbClr val="A9B4C2"/>
                 </a:solidFill>
                 <a:latin typeface="DM Sans"/>
               </a:rPr>
-              <a:t>clé d'identité pour révoquer seul sa clé volée · clé de contrainte qui dit « oui » à l'écran et gèle en silence · probation des clés neuves.</a:t>
-            </a:r>
-          </a:p>
-        </p:txBody>
-      </p:sp>
-      <p:sp>
-        <p:nvSpPr>
-          <p:cNvPr id="40" name="TextBox 39"/>
-          <p:cNvSpPr txBox="1"/>
-          <p:nvPr/>
-        </p:nvSpPr>
-        <p:spPr>
-          <a:xfrm>
-            <a:off x="731520" y="5897880"/>
-            <a:ext cx="10728655" cy="274320"/>
-          </a:xfrm>
-          <a:prstGeom prst="rect">
-            <a:avLst/>
-          </a:prstGeom>
-          <a:noFill/>
-        </p:spPr>
-        <p:txBody>
-          <a:bodyPr wrap="square" anchor="t" lIns="0" rIns="0" tIns="0" bIns="0">
-            <a:spAutoFit/>
-          </a:bodyPr>
-          <a:lstStyle/>
-          <a:p>
-            <a:pPr algn="l">
-              <a:lnSpc>
-                <a:spcPct val="115000"/>
-              </a:lnSpc>
-            </a:pPr>
-            <a:r>
-              <a:rPr sz="950" b="0">
-                <a:solidFill>
-                  <a:srgbClr val="7F8B9B"/>
+              <a:t> (signature en plus, mise en attente : rien n'est jamais bloqué) · </a:t>
+            </a:r>
+            <a:r>
+              <a:rPr sz="1300" b="1">
+                <a:solidFill>
+                  <a:srgbClr val="FFC481"/>
                 </a:solidFill>
                 <a:latin typeface="DM Sans"/>
               </a:rPr>
-              <a:t>shared/ce-que-breaker-est.md · ia-1/score/regles.py · ia-2/contracts/TreasuryGuard.sol</a:t>
+              <a:t>Cosignataire</a:t>
+            </a:r>
+            <a:r>
+              <a:rPr sz="1300" b="0">
+                <a:solidFill>
+                  <a:srgbClr val="A9B4C2"/>
+                </a:solidFill>
+                <a:latin typeface="DM Sans"/>
+              </a:rPr>
+              <a:t> (un agent occupe un siège de signataire et refuse ; dérogation humaine après délai).</a:t>
             </a:r>
           </a:p>
         </p:txBody>
@@ -14903,7 +14913,7 @@
                 </a:solidFill>
                 <a:latin typeface="DM Sans"/>
               </a:rPr>
-              <a:t>des fraudes freinées ou arrêtées, formes jamais vues</a:t>
+              <a:t>des fraudes freinées ou mises en attente, formes jamais vues</a:t>
             </a:r>
           </a:p>
         </p:txBody>
@@ -15243,7 +15253,7 @@
                 </a:solidFill>
                 <a:latin typeface="DM Sans"/>
               </a:rPr>
-              <a:t>de paiements légitimes retardés : gros premiers paiements ; 0 % sur les récurrents</a:t>
+              <a:t>de paiements légitimes retardés, tous des premiers paiements</a:t>
             </a:r>
           </a:p>
         </p:txBody>
@@ -15924,45 +15934,6 @@
                 <a:latin typeface="DM Sans"/>
               </a:rPr>
               <a:t>données fabriquées par nous · contrat pas encore audité par un tiers</a:t>
-            </a:r>
-          </a:p>
-        </p:txBody>
-      </p:sp>
-      <p:sp>
-        <p:nvSpPr>
-          <p:cNvPr id="41" name="TextBox 40"/>
-          <p:cNvSpPr txBox="1"/>
-          <p:nvPr/>
-        </p:nvSpPr>
-        <p:spPr>
-          <a:xfrm>
-            <a:off x="731520" y="5897880"/>
-            <a:ext cx="10728655" cy="274320"/>
-          </a:xfrm>
-          <a:prstGeom prst="rect">
-            <a:avLst/>
-          </a:prstGeom>
-          <a:noFill/>
-        </p:spPr>
-        <p:txBody>
-          <a:bodyPr wrap="square" anchor="t" lIns="0" rIns="0" tIns="0" bIns="0">
-            <a:spAutoFit/>
-          </a:bodyPr>
-          <a:lstStyle/>
-          <a:p>
-            <a:pPr algn="l">
-              <a:lnSpc>
-                <a:spcPct val="115000"/>
-              </a:lnSpc>
-            </a:pPr>
-            <a:r>
-              <a:rPr sz="950" b="0">
-                <a:solidFill>
-                  <a:srgbClr val="7F8B9B"/>
-                </a:solidFill>
-                <a:latin typeface="DM Sans"/>
-              </a:rPr>
-              <a:t>shared/mesures.md § 1 · shared/audit-contrat.md · explorateur Fuji : adresses dans ia-2/deployments/fuji.json</a:t>
             </a:r>
           </a:p>
         </p:txBody>
@@ -16518,8 +16489,8 @@
         </p:nvSpPr>
         <p:spPr>
           <a:xfrm>
-            <a:off x="731520" y="2240280"/>
-            <a:ext cx="2545003" cy="1828800"/>
+            <a:off x="731520" y="2194560"/>
+            <a:ext cx="2545003" cy="1965960"/>
           </a:xfrm>
           <a:prstGeom prst="roundRect">
             <a:avLst>
@@ -16566,7 +16537,7 @@
         </p:nvSpPr>
         <p:spPr>
           <a:xfrm>
-            <a:off x="1005840" y="2441448"/>
+            <a:off x="1005840" y="2395728"/>
             <a:ext cx="2087803" cy="365760"/>
           </a:xfrm>
           <a:prstGeom prst="rect">
@@ -16605,7 +16576,7 @@
         </p:nvSpPr>
         <p:spPr>
           <a:xfrm>
-            <a:off x="1005840" y="2788920"/>
+            <a:off x="1005840" y="2743200"/>
             <a:ext cx="2087803" cy="640080"/>
           </a:xfrm>
           <a:prstGeom prst="rect">
@@ -16653,7 +16624,7 @@
         </p:nvSpPr>
         <p:spPr>
           <a:xfrm>
-            <a:off x="1005840" y="3429000"/>
+            <a:off x="1005840" y="3383280"/>
             <a:ext cx="2087803" cy="640080"/>
           </a:xfrm>
           <a:prstGeom prst="rect">
@@ -16692,8 +16663,8 @@
         </p:nvSpPr>
         <p:spPr>
           <a:xfrm>
-            <a:off x="3459403" y="2240280"/>
-            <a:ext cx="2545003" cy="1828800"/>
+            <a:off x="3459403" y="2194560"/>
+            <a:ext cx="2545003" cy="1965960"/>
           </a:xfrm>
           <a:prstGeom prst="roundRect">
             <a:avLst>
@@ -16740,7 +16711,7 @@
         </p:nvSpPr>
         <p:spPr>
           <a:xfrm>
-            <a:off x="3733723" y="2441448"/>
+            <a:off x="3733723" y="2395728"/>
             <a:ext cx="2087803" cy="365760"/>
           </a:xfrm>
           <a:prstGeom prst="rect">
@@ -16779,7 +16750,7 @@
         </p:nvSpPr>
         <p:spPr>
           <a:xfrm>
-            <a:off x="3733723" y="2788920"/>
+            <a:off x="3733723" y="2743200"/>
             <a:ext cx="2087803" cy="640080"/>
           </a:xfrm>
           <a:prstGeom prst="rect">
@@ -16827,7 +16798,7 @@
         </p:nvSpPr>
         <p:spPr>
           <a:xfrm>
-            <a:off x="3733723" y="3429000"/>
+            <a:off x="3733723" y="3383280"/>
             <a:ext cx="2087803" cy="640080"/>
           </a:xfrm>
           <a:prstGeom prst="rect">
@@ -16866,8 +16837,8 @@
         </p:nvSpPr>
         <p:spPr>
           <a:xfrm>
-            <a:off x="6187286" y="2240280"/>
-            <a:ext cx="2545003" cy="1828800"/>
+            <a:off x="6187286" y="2194560"/>
+            <a:ext cx="2545003" cy="1965960"/>
           </a:xfrm>
           <a:prstGeom prst="roundRect">
             <a:avLst>
@@ -16914,7 +16885,7 @@
         </p:nvSpPr>
         <p:spPr>
           <a:xfrm>
-            <a:off x="6461606" y="2441448"/>
+            <a:off x="6461606" y="2395728"/>
             <a:ext cx="2087803" cy="365760"/>
           </a:xfrm>
           <a:prstGeom prst="rect">
@@ -16953,7 +16924,7 @@
         </p:nvSpPr>
         <p:spPr>
           <a:xfrm>
-            <a:off x="6461606" y="2788920"/>
+            <a:off x="6461606" y="2743200"/>
             <a:ext cx="2087803" cy="640080"/>
           </a:xfrm>
           <a:prstGeom prst="rect">
@@ -17001,7 +16972,7 @@
         </p:nvSpPr>
         <p:spPr>
           <a:xfrm>
-            <a:off x="6461606" y="3429000"/>
+            <a:off x="6461606" y="3383280"/>
             <a:ext cx="2087803" cy="640080"/>
           </a:xfrm>
           <a:prstGeom prst="rect">
@@ -17027,7 +16998,7 @@
                 </a:solidFill>
                 <a:latin typeface="DM Sans"/>
               </a:rPr>
-              <a:t>1 à 10 M$ · + oracle Web, traçage, sosies, clé d'identité, rapport mensuel</a:t>
+              <a:t>1 à 10 M$ · + oracle Web, traçage, sosies, clé d'identité, Cosignataire en option</a:t>
             </a:r>
           </a:p>
         </p:txBody>
@@ -17040,8 +17011,8 @@
         </p:nvSpPr>
         <p:spPr>
           <a:xfrm>
-            <a:off x="8915169" y="2240280"/>
-            <a:ext cx="2545003" cy="1828800"/>
+            <a:off x="8915169" y="2194560"/>
+            <a:ext cx="2545003" cy="1965960"/>
           </a:xfrm>
           <a:prstGeom prst="roundRect">
             <a:avLst>
@@ -17088,7 +17059,7 @@
         </p:nvSpPr>
         <p:spPr>
           <a:xfrm>
-            <a:off x="9189489" y="2441448"/>
+            <a:off x="9189489" y="2395728"/>
             <a:ext cx="2087803" cy="365760"/>
           </a:xfrm>
           <a:prstGeom prst="rect">
@@ -17127,7 +17098,7 @@
         </p:nvSpPr>
         <p:spPr>
           <a:xfrm>
-            <a:off x="9189489" y="2788920"/>
+            <a:off x="9189489" y="2743200"/>
             <a:ext cx="2087803" cy="640080"/>
           </a:xfrm>
           <a:prstGeom prst="rect">
@@ -17175,7 +17146,7 @@
         </p:nvSpPr>
         <p:spPr>
           <a:xfrm>
-            <a:off x="9189489" y="3429000"/>
+            <a:off x="9189489" y="3383280"/>
             <a:ext cx="2087803" cy="640080"/>
           </a:xfrm>
           <a:prstGeom prst="rect">
@@ -17201,7 +17172,7 @@
                 </a:solidFill>
                 <a:latin typeface="DM Sans"/>
               </a:rPr>
-              <a:t>&gt; 10 M$ · + mode cosignataire, réglages sur mesure, support · Entreprise sur devis</a:t>
+              <a:t>&gt; 10 M$ ou &gt; 5 multisigs · sur mesure, support prioritaire, disponibilité garantie · Entreprise sur devis</a:t>
             </a:r>
           </a:p>
         </p:txBody>
@@ -17214,7 +17185,7 @@
         </p:nvSpPr>
         <p:spPr>
           <a:xfrm>
-            <a:off x="731520" y="4315968"/>
+            <a:off x="731520" y="4453128"/>
             <a:ext cx="2788920" cy="329184"/>
           </a:xfrm>
           <a:prstGeom prst="rect">
@@ -17253,7 +17224,7 @@
         </p:nvSpPr>
         <p:spPr>
           <a:xfrm>
-            <a:off x="3657600" y="4315968"/>
+            <a:off x="3657600" y="4453128"/>
             <a:ext cx="7665415" cy="329184"/>
           </a:xfrm>
           <a:prstGeom prst="rect">
@@ -17292,7 +17263,7 @@
         </p:nvSpPr>
         <p:spPr>
           <a:xfrm>
-            <a:off x="731520" y="4575144"/>
+            <a:off x="731520" y="4712304"/>
             <a:ext cx="10728655" cy="6000"/>
           </a:xfrm>
           <a:prstGeom prst="rect">
@@ -17336,7 +17307,7 @@
         </p:nvSpPr>
         <p:spPr>
           <a:xfrm>
-            <a:off x="731520" y="4645152"/>
+            <a:off x="731520" y="4782312"/>
             <a:ext cx="2788920" cy="329184"/>
           </a:xfrm>
           <a:prstGeom prst="rect">
@@ -17375,7 +17346,7 @@
         </p:nvSpPr>
         <p:spPr>
           <a:xfrm>
-            <a:off x="3657600" y="4645152"/>
+            <a:off x="3657600" y="4782312"/>
             <a:ext cx="7665415" cy="329184"/>
           </a:xfrm>
           <a:prstGeom prst="rect">
@@ -17414,7 +17385,7 @@
         </p:nvSpPr>
         <p:spPr>
           <a:xfrm>
-            <a:off x="731520" y="4904328"/>
+            <a:off x="731520" y="5041488"/>
             <a:ext cx="10728655" cy="6000"/>
           </a:xfrm>
           <a:prstGeom prst="rect">
@@ -17458,7 +17429,7 @@
         </p:nvSpPr>
         <p:spPr>
           <a:xfrm>
-            <a:off x="731520" y="4974336"/>
+            <a:off x="731520" y="5111496"/>
             <a:ext cx="2788920" cy="329184"/>
           </a:xfrm>
           <a:prstGeom prst="rect">
@@ -17497,7 +17468,7 @@
         </p:nvSpPr>
         <p:spPr>
           <a:xfrm>
-            <a:off x="3657600" y="4974336"/>
+            <a:off x="3657600" y="5111496"/>
             <a:ext cx="7665415" cy="329184"/>
           </a:xfrm>
           <a:prstGeom prst="rect">
@@ -17536,7 +17507,7 @@
         </p:nvSpPr>
         <p:spPr>
           <a:xfrm>
-            <a:off x="731520" y="5233512"/>
+            <a:off x="731520" y="5370672"/>
             <a:ext cx="10728655" cy="6000"/>
           </a:xfrm>
           <a:prstGeom prst="rect">
@@ -17580,7 +17551,7 @@
         </p:nvSpPr>
         <p:spPr>
           <a:xfrm>
-            <a:off x="731520" y="5303520"/>
+            <a:off x="731520" y="5440680"/>
             <a:ext cx="2788920" cy="329184"/>
           </a:xfrm>
           <a:prstGeom prst="rect">
@@ -17619,7 +17590,7 @@
         </p:nvSpPr>
         <p:spPr>
           <a:xfrm>
-            <a:off x="3657600" y="5303520"/>
+            <a:off x="3657600" y="5440680"/>
             <a:ext cx="7665415" cy="329184"/>
           </a:xfrm>
           <a:prstGeom prst="rect">
@@ -17658,7 +17629,7 @@
         </p:nvSpPr>
         <p:spPr>
           <a:xfrm>
-            <a:off x="731520" y="5562696"/>
+            <a:off x="731520" y="5699856"/>
             <a:ext cx="10728655" cy="6000"/>
           </a:xfrm>
           <a:prstGeom prst="rect">
@@ -17691,45 +17662,6 @@
           <a:lstStyle/>
           <a:p>
             <a:pPr algn="ctr"/>
-          </a:p>
-        </p:txBody>
-      </p:sp>
-      <p:sp>
-        <p:nvSpPr>
-          <p:cNvPr id="41" name="TextBox 40"/>
-          <p:cNvSpPr txBox="1"/>
-          <p:nvPr/>
-        </p:nvSpPr>
-        <p:spPr>
-          <a:xfrm>
-            <a:off x="731520" y="5897880"/>
-            <a:ext cx="10728655" cy="274320"/>
-          </a:xfrm>
-          <a:prstGeom prst="rect">
-            <a:avLst/>
-          </a:prstGeom>
-          <a:noFill/>
-        </p:spPr>
-        <p:txBody>
-          <a:bodyPr wrap="square" anchor="t" lIns="0" rIns="0" tIns="0" bIns="0">
-            <a:spAutoFit/>
-          </a:bodyPr>
-          <a:lstStyle/>
-          <a:p>
-            <a:pPr algn="l">
-              <a:lnSpc>
-                <a:spcPct val="115000"/>
-              </a:lnSpc>
-            </a:pPr>
-            <a:r>
-              <a:rPr sz="950" b="0">
-                <a:solidFill>
-                  <a:srgbClr val="7F8B9B"/>
-                </a:solidFill>
-                <a:latin typeface="DM Sans"/>
-              </a:rPr>
-              <a:t>shared/business-prix.md · shared/business-safe-et-differenciation.md · safe.global/pricing (8/10/2026)</a:t>
-            </a:r>
           </a:p>
         </p:txBody>
       </p:sp>
@@ -18562,7 +18494,7 @@
                 </a:solidFill>
                 <a:latin typeface="DM Sans"/>
               </a:rPr>
-              <a:t>× 50 % : hypothèse H4, la seule non sourcée, mesurée dès octobre (± 12 points)</a:t>
+              <a:t>× 50 % : une équipe sur deux accepte l'essai gratuit ; seule hypothèse non sourcée, mesurée dès octobre</a:t>
             </a:r>
           </a:p>
         </p:txBody>
@@ -19093,7 +19025,7 @@
                 </a:solidFill>
                 <a:latin typeface="DM Sans"/>
               </a:rPr>
-              <a:t>portage en Guard + Module de Safe · mesure de H4 · faux positifs réels &lt; 5 %</a:t>
+              <a:t>greffon sur le Safe du client · mesurer la part des équipes qui acceptent l'essai (hypothèse : une sur deux)</a:t>
             </a:r>
           </a:p>
         </p:txBody>
@@ -19420,7 +19352,7 @@
                 </a:solidFill>
                 <a:latin typeface="DM Sans"/>
               </a:rPr>
-              <a:t>fin 2027 – mi-2028</a:t>
+              <a:t>T3 2027 – mi-2028</a:t>
             </a:r>
           </a:p>
         </p:txBody>
@@ -19459,7 +19391,7 @@
                 </a:solidFill>
                 <a:latin typeface="DM Sans"/>
               </a:rPr>
-              <a:t>point mort : 17 clients Standard (7 300 €/mois de coûts fixes) ; plus tôt avec un client Premium</a:t>
+              <a:t>point mort : 10 clients Standard (coûts fixes 4 300 €/mois : 2 fondateurs à 2 000 € + 300 € d'infra) ; plus tôt avec un Premium</a:t>
             </a:r>
           </a:p>
         </p:txBody>
@@ -19505,45 +19437,6 @@
           <a:lstStyle/>
           <a:p>
             <a:pPr algn="ctr"/>
-          </a:p>
-        </p:txBody>
-      </p:sp>
-      <p:sp>
-        <p:nvSpPr>
-          <p:cNvPr id="43" name="TextBox 42"/>
-          <p:cNvSpPr txBox="1"/>
-          <p:nvPr/>
-        </p:nvSpPr>
-        <p:spPr>
-          <a:xfrm>
-            <a:off x="731520" y="5897880"/>
-            <a:ext cx="10728655" cy="274320"/>
-          </a:xfrm>
-          <a:prstGeom prst="rect">
-            <a:avLst/>
-          </a:prstGeom>
-          <a:noFill/>
-        </p:spPr>
-        <p:txBody>
-          <a:bodyPr wrap="square" anchor="t" lIns="0" rIns="0" tIns="0" bIns="0">
-            <a:spAutoFit/>
-          </a:bodyPr>
-          <a:lstStyle/>
-          <a:p>
-            <a:pPr algn="l">
-              <a:lnSpc>
-                <a:spcPct val="115000"/>
-              </a:lnSpc>
-            </a:pPr>
-            <a:r>
-              <a:rPr sz="950" b="0">
-                <a:solidFill>
-                  <a:srgbClr val="7F8B9B"/>
-                </a:solidFill>
-                <a:latin typeface="DM Sans"/>
-              </a:rPr>
-              <a:t>shared/business-marche.md § 3 · shared/business-mise-sur-le-marche.md § 3 et 3 bis</a:t>
-            </a:r>
           </a:p>
         </p:txBody>
       </p:sp>
@@ -20195,7 +20088,7 @@
                 </a:solidFill>
                 <a:latin typeface="DM Sans"/>
               </a:rPr>
-              <a:t>•  Le multisig de la démo tient lieu du Safe du client : le greffon reste à écrire.</a:t>
+              <a:t>•  Le coffre de la démo tient lieu du Safe du client : le greffon reste à écrire.</a:t>
             </a:r>
           </a:p>
           <a:p>
@@ -20305,7 +20198,7 @@
                 </a:solidFill>
                 <a:latin typeface="DM Sans"/>
               </a:rPr>
-              <a:t>•  Portage en Guard + Module de Safe · notifications · rejeu de Bybit et Drift sur données réelles.</a:t>
+              <a:t>•  Greffon sur le Safe du client · notifications · rejeu de Bybit et Drift sur données réelles.</a:t>
             </a:r>
           </a:p>
           <a:p>
@@ -20405,45 +20298,6 @@
                 <a:latin typeface="Manrope"/>
               </a:rPr>
               <a:t>Vos fonds. Vos signataires. Votre dernier mot.</a:t>
-            </a:r>
-          </a:p>
-        </p:txBody>
-      </p:sp>
-      <p:sp>
-        <p:nvSpPr>
-          <p:cNvPr id="19" name="TextBox 18"/>
-          <p:cNvSpPr txBox="1"/>
-          <p:nvPr/>
-        </p:nvSpPr>
-        <p:spPr>
-          <a:xfrm>
-            <a:off x="1005840" y="5623560"/>
-            <a:ext cx="10728655" cy="365760"/>
-          </a:xfrm>
-          <a:prstGeom prst="rect">
-            <a:avLst/>
-          </a:prstGeom>
-          <a:noFill/>
-        </p:spPr>
-        <p:txBody>
-          <a:bodyPr wrap="square" anchor="t" lIns="0" rIns="0" tIns="0" bIns="0">
-            <a:spAutoFit/>
-          </a:bodyPr>
-          <a:lstStyle/>
-          <a:p>
-            <a:pPr algn="l">
-              <a:lnSpc>
-                <a:spcPct val="115000"/>
-              </a:lnSpc>
-            </a:pPr>
-            <a:r>
-              <a:rPr sz="1100" b="0">
-                <a:solidFill>
-                  <a:srgbClr val="7F8B9B"/>
-                </a:solidFill>
-                <a:latin typeface="DM Sans"/>
-              </a:rPr>
-              <a:t>Romain, business · Timéo, technique · github.com/veryromain/hackathon-ia-cyber-romain-timeo</a:t>
             </a:r>
           </a:p>
         </p:txBody>

</xml_diff>

<commit_message>
[shared] offre = gradation (une personne / du temps / un refus), Premium détaché de la taille de trésorerie, deck corrigé
</commit_message>
<xml_diff>
--- a/shared/pitch/Breaker-pitch.pptx
+++ b/shared/pitch/Breaker-pitch.pptx
@@ -625,7 +625,7 @@
           </a:p>
           <a:p>
             <a:r>
-              <a:t>Où interviennent les agents : partout pour regarder et expliquer (automatique, toujours). Pour DÉCIDER, seulement si le client a activé le mode Cosignataire : l'agent devient un signataire qui peut refuser. En mode Protection, l'agent ne signe jamais et ne refuse jamais : il ajoute une signature à obtenir ou un délai.</a:t>
+              <a:t>Où interviennent les agents : partout pour regarder et expliquer (automatique, toujours). Pour DÉCIDER, seulement au niveau Premium (mode Cosignataire) : l'agent devient un signataire qui peut refuser. En mode Protection, l'agent ne signe jamais et ne refuse jamais : il ajoute une signature à obtenir ou un délai.</a:t>
             </a:r>
           </a:p>
           <a:p>
@@ -1048,7 +1048,7 @@
           </a:p>
           <a:p>
             <a:r>
-              <a:t>Trois : elle freine. Une signature de plus, ou une mise en attente : un délai pendant lequel rien ne part, même avec toutes les signatures. Jamais un blocage définitif : l'unanimité de vos signataires lève tout. Et si vous voulez qu'elle puisse dire non, vous activez le mode Cosignataire : un agent prend un siège de signataire et refuse de signer un paiement à risque ; vos signataires gardent une dérogation après délai.</a:t>
+              <a:t>Trois : elle freine. Une signature de plus, ou une mise en attente : un délai pendant lequel rien ne part, même avec toutes les signatures. Jamais un blocage définitif : l'unanimité de vos signataires lève tout. Et si vous voulez qu'elle puisse dire non à votre place, c'est le niveau Premium, le mode Cosignataire : un agent prend un siège de signataire et refuse de signer un paiement à risque ; vos signataires gardent une dérogation après délai.</a:t>
             </a:r>
           </a:p>
           <a:p>
@@ -1241,49 +1241,70 @@
           </a:p>
           <a:p>
             <a:r>
-              <a:t>Observation gratuite 30 jours : rien ne change à vos paiements. Puis 149, 449 ou 990 euros par mois selon la trésorerie, sans engagement.</a:t>
-            </a:r>
-          </a:p>
-          <a:p>
-            <a:r>
-              <a:t>449 euros, c'est 5 % de la perte annuelle que vous évitez, calculée avec les taux d'incidents de TRM et notre efficacité mesurée. Et le mode Cosignataire, l'agent qui peut dire non, est disponible dès cette formule : c'est vous qui choisissez le pouvoir que vous lui déléguez. »</a:t>
+              <a:t>Observation gratuite 30 jours : rien ne change à vos paiements. Puis trois niveaux, selon le pouvoir que vous nous déléguez : Essentiel, 149 euros, une personne de plus sur les paiements inhabituels. Standard, 449 euros, du temps : la mise en attente, et la protection de la personne. Premium, 990 euros, un refus : un agent qui occupe un siège de signataire et peut dire non à votre place. Sans engagement.</a:t>
+            </a:r>
+          </a:p>
+          <a:p>
+            <a:r>
+              <a:t>449 euros, c'est 5 % de la perte annuelle que vous évitez, calculée avec les taux d'incidents de TRM et notre efficacité mesurée ; 990 euros, c'est 10 %, le plafond de ce qu'un outil de sécurité peut demander. »</a:t>
             </a:r>
           </a:p>
           <a:p/>
           <a:p>
             <a:r>
-              <a:t>LE CALCUL DE LA PERTE ANNUELLE ÉVITÉE, si on nous le demande (tout est dans shared/business-prix.md § 1.B) :</a:t>
-            </a:r>
-          </a:p>
-          <a:p>
-            <a:r>
-              <a:t>• Probabilité d'un incident dans l'année ≈ 9,5 % : TRM Labs compte ≈ 150 incidents significatifs en 2025 ; on les rapporte à la population des organisations qui ont au moins 1 M$ : 1 359 protocoles avec plus de 1 M$ d'actifs (API DeFiLlama) + 220 DAO avec plus de 1 M$ de trésorerie (DeepDAO) = 1 579. 150 / 1 579 = 9,5 %. C'est une borne haute : tous ces incidents ne sont pas des fraudes de signataires ; on montre aussi le cas où un incident sur cinq est dans notre périmètre.</a:t>
-            </a:r>
-          </a:p>
-          <a:p>
-            <a:r>
-              <a:t>• Perte médiane par incident = 1,3 M$ : médiane des incidents significatifs de 2025 selon TRM Labs (la moitié des incidents coûtent plus, la moitié moins). Deux autres sources l'encadrent : Immunefi donne 1,5 M$ de médiane en DeFi ; CertiK donne 104 k$ mais sur un périmètre beaucoup plus large qui inclut les petits incidents (plus de 700). On prend TRM parce que son périmètre (incidents significatifs) ressemble au nôtre.</a:t>
-            </a:r>
-          </a:p>
-          <a:p>
-            <a:r>
-              <a:t>• Efficacité = 91 % : part des montants frauduleux que Breaker a mis en attente sur le jeu final, préparé à l'aveugle (shared/mesures.md).</a:t>
-            </a:r>
-          </a:p>
-          <a:p>
-            <a:r>
-              <a:t>• Perte évitée = 9,5 % × 1,3 M$ × 91 % ≈ 112 k$ par an ; 22 k$ si un incident sur cinq est dans notre périmètre.</a:t>
-            </a:r>
-          </a:p>
-          <a:p>
-            <a:r>
-              <a:t>• Règle de prix : un outil de sécurité se vend sans discussion sous 10 % de la perte qu'il évite ; 449 € × 12 = 5 400 € = 5 % de 112 k$ (25 % de 22 k$).</a:t>
+              <a:t>POURQUOI UN CLIENT PAIE 990 € PLUTÔT QUE 449 € (si on nous le demande) :</a:t>
+            </a:r>
+          </a:p>
+          <a:p>
+            <a:r>
+              <a:t>• Ce qu'il achète en plus : le seul niveau où quelqu'un peut dire NON à sa place. La signature en plus et la mise en attente supposent qu'au moins un humain réagisse ; chez Bybit, les trois signataires ont validé ; chez Drift, les signataires ont approuvé. Le Cosignataire couvre le cas où tous les humains sont trompés ou sous pression.</a:t>
+            </a:r>
+          </a:p>
+          <a:p>
+            <a:r>
+              <a:t>• Pour qui : les organisations dont les signataires sont dispersés ou peu disponibles (DAO), celles dont la trésorerie dépasse 10 M$, celles qui veulent une disponibilité garantie. Premium n'est PAS réservé aux grandes trésoreries : c'est un niveau de pouvoir délégué, accessible à tous.</a:t>
+            </a:r>
+          </a:p>
+          <a:p>
+            <a:r>
+              <a:t>• Valeur : 990 € × 12 = 11,9 k€ = 10 % de 112 k$ de perte annuelle évitée ; c'est le plafond de la règle « ≤ 10 % », là où Standard est à 5 %. Repère de marché pour l'automatisation : Fireblocks Essentials à 999 $/mois.</a:t>
+            </a:r>
+          </a:p>
+          <a:p>
+            <a:r>
+              <a:t>• Garde-fou : même en Premium, l'agent n'a jamais de veto définitif : dérogation humaine renforcée après délai (décision Timéo, shared/decisions.md).</a:t>
             </a:r>
           </a:p>
           <a:p/>
           <a:p>
             <a:r>
-              <a:t>Différence en une phrase si on nous la demande : « Vous avez déjà le coffre. Il vous manque quelqu'un qui regarde chaque paiement et vous dit, en français, quand quelque chose ne colle pas. »</a:t>
+              <a:t>LE CALCUL DE LA PERTE ANNUELLE ÉVITÉE (shared/business-prix.md § 1.B) :</a:t>
+            </a:r>
+          </a:p>
+          <a:p>
+            <a:r>
+              <a:t>• 9,5 % : TRM Labs compte ≈ 150 incidents significatifs en 2025, rapportés aux 1 579 organisations ≥ 1 M$ (1 359 protocoles &gt; 1 M$ d'actifs, API DeFiLlama, + 220 DAO &gt; 1 M$, DeepDAO). Borne haute : on montre aussi le cas « un incident sur cinq dans notre périmètre » (22 k$).</a:t>
+            </a:r>
+          </a:p>
+          <a:p>
+            <a:r>
+              <a:t>• 1,3 M$ : perte médiane des incidents significatifs de 2025 selon TRM Labs (la moitié coûtent plus, la moitié moins). Immunefi donne 1,5 M$ en DeFi ; CertiK 104 k$ mais sur plus de 700 incidents dont beaucoup de petits. On prend TRM, dont le périmètre ressemble au nôtre.</a:t>
+            </a:r>
+          </a:p>
+          <a:p>
+            <a:r>
+              <a:t>• 91 % : part des montants frauduleux mis en attente sur le jeu final préparé à l'aveugle (shared/mesures.md).</a:t>
+            </a:r>
+          </a:p>
+          <a:p>
+            <a:r>
+              <a:t>• 9,5 % × 1,3 M$ × 91 % ≈ 112 k$/an.</a:t>
+            </a:r>
+          </a:p>
+          <a:p/>
+          <a:p>
+            <a:r>
+              <a:t>Différence en une phrase : « Vous avez déjà le coffre. Il vous manque quelqu'un qui regarde chaque paiement et vous dit, en français, quand quelque chose ne colle pas. »</a:t>
             </a:r>
           </a:p>
         </p:txBody>
@@ -6128,7 +6149,7 @@
                 </a:solidFill>
                 <a:latin typeface="DM Sans"/>
               </a:rPr>
-              <a:t>Signature en plus (score ≥ 0,30)</a:t>
+              <a:t>Signature en plus · Essentiel (score ≥ 0,30)</a:t>
             </a:r>
           </a:p>
         </p:txBody>
@@ -6367,7 +6388,7 @@
                 </a:solidFill>
                 <a:latin typeface="DM Sans"/>
               </a:rPr>
-              <a:t>Mise en attente (score ≥ 0,75)</a:t>
+              <a:t>Mise en attente · Standard (score ≥ 0,75)</a:t>
             </a:r>
           </a:p>
         </p:txBody>
@@ -6606,7 +6627,7 @@
                 </a:solidFill>
                 <a:latin typeface="DM Sans"/>
               </a:rPr>
-              <a:t>Cosignataire (option, dès Standard)</a:t>
+              <a:t>Cosignataire · Premium</a:t>
             </a:r>
           </a:p>
         </p:txBody>
@@ -6645,7 +6666,7 @@
                 </a:solidFill>
                 <a:latin typeface="DM Sans"/>
               </a:rPr>
-              <a:t>mêmes signaux ; le client a activé le mode</a:t>
+              <a:t>mêmes signaux ; le client a choisi ce niveau</a:t>
             </a:r>
           </a:p>
         </p:txBody>
@@ -6845,7 +6866,7 @@
                 </a:solidFill>
                 <a:latin typeface="DM Sans"/>
               </a:rPr>
-              <a:t>Gel</a:t>
+              <a:t>Gel · Standard</a:t>
             </a:r>
           </a:p>
         </p:txBody>
@@ -7733,7 +7754,7 @@
         <p:spPr>
           <a:xfrm>
             <a:off x="1005840" y="3054096"/>
-            <a:ext cx="2074087" cy="548640"/>
+            <a:ext cx="2074087" cy="594360"/>
           </a:xfrm>
           <a:prstGeom prst="rect">
             <a:avLst/>
@@ -7748,11 +7769,11 @@
           <a:p>
             <a:pPr algn="l">
               <a:lnSpc>
-                <a:spcPct val="115000"/>
-              </a:lnSpc>
-            </a:pPr>
-            <a:r>
-              <a:rPr sz="1250" b="0">
+                <a:spcPct val="112000"/>
+              </a:lnSpc>
+            </a:pPr>
+            <a:r>
+              <a:rPr sz="1150" b="0">
                 <a:solidFill>
                   <a:srgbClr val="A9B4C2"/>
                 </a:solidFill>
@@ -7903,7 +7924,7 @@
         <p:spPr>
           <a:xfrm>
             <a:off x="3738295" y="3054096"/>
-            <a:ext cx="2074087" cy="548640"/>
+            <a:ext cx="2074087" cy="594360"/>
           </a:xfrm>
           <a:prstGeom prst="rect">
             <a:avLst/>
@@ -7918,11 +7939,11 @@
           <a:p>
             <a:pPr algn="l">
               <a:lnSpc>
-                <a:spcPct val="115000"/>
-              </a:lnSpc>
-            </a:pPr>
-            <a:r>
-              <a:rPr sz="1250" b="0">
+                <a:spcPct val="112000"/>
+              </a:lnSpc>
+            </a:pPr>
+            <a:r>
+              <a:rPr sz="1150" b="0">
                 <a:solidFill>
                   <a:srgbClr val="A9B4C2"/>
                 </a:solidFill>
@@ -8073,7 +8094,7 @@
         <p:spPr>
           <a:xfrm>
             <a:off x="6470750" y="3054096"/>
-            <a:ext cx="2074087" cy="548640"/>
+            <a:ext cx="2074087" cy="594360"/>
           </a:xfrm>
           <a:prstGeom prst="rect">
             <a:avLst/>
@@ -8088,11 +8109,11 @@
           <a:p>
             <a:pPr algn="l">
               <a:lnSpc>
-                <a:spcPct val="115000"/>
-              </a:lnSpc>
-            </a:pPr>
-            <a:r>
-              <a:rPr sz="1250" b="0">
+                <a:spcPct val="112000"/>
+              </a:lnSpc>
+            </a:pPr>
+            <a:r>
+              <a:rPr sz="1150" b="0">
                 <a:solidFill>
                   <a:srgbClr val="A9B4C2"/>
                 </a:solidFill>
@@ -8243,7 +8264,7 @@
         <p:spPr>
           <a:xfrm>
             <a:off x="9203205" y="3054096"/>
-            <a:ext cx="2074087" cy="548640"/>
+            <a:ext cx="2074087" cy="594360"/>
           </a:xfrm>
           <a:prstGeom prst="rect">
             <a:avLst/>
@@ -8258,11 +8279,11 @@
           <a:p>
             <a:pPr algn="l">
               <a:lnSpc>
-                <a:spcPct val="115000"/>
-              </a:lnSpc>
-            </a:pPr>
-            <a:r>
-              <a:rPr sz="1250" b="0">
+                <a:spcPct val="112000"/>
+              </a:lnSpc>
+            </a:pPr>
+            <a:r>
+              <a:rPr sz="1150" b="0">
                 <a:solidFill>
                   <a:srgbClr val="A9B4C2"/>
                 </a:solidFill>
@@ -10790,7 +10811,7 @@
         <p:spPr>
           <a:xfrm>
             <a:off x="1005840" y="3374136"/>
-            <a:ext cx="2984906" cy="685800"/>
+            <a:ext cx="2984906" cy="731520"/>
           </a:xfrm>
           <a:prstGeom prst="rect">
             <a:avLst/>
@@ -10805,11 +10826,11 @@
           <a:p>
             <a:pPr algn="l">
               <a:lnSpc>
-                <a:spcPct val="115000"/>
-              </a:lnSpc>
-            </a:pPr>
-            <a:r>
-              <a:rPr sz="1250" b="0">
+                <a:spcPct val="112000"/>
+              </a:lnSpc>
+            </a:pPr>
+            <a:r>
+              <a:rPr sz="1150" b="0">
                 <a:solidFill>
                   <a:srgbClr val="A9B4C2"/>
                 </a:solidFill>
@@ -10960,7 +10981,7 @@
         <p:spPr>
           <a:xfrm>
             <a:off x="4649114" y="3374136"/>
-            <a:ext cx="2984906" cy="685800"/>
+            <a:ext cx="2984906" cy="731520"/>
           </a:xfrm>
           <a:prstGeom prst="rect">
             <a:avLst/>
@@ -10975,11 +10996,11 @@
           <a:p>
             <a:pPr algn="l">
               <a:lnSpc>
-                <a:spcPct val="115000"/>
-              </a:lnSpc>
-            </a:pPr>
-            <a:r>
-              <a:rPr sz="1250" b="0">
+                <a:spcPct val="112000"/>
+              </a:lnSpc>
+            </a:pPr>
+            <a:r>
+              <a:rPr sz="1150" b="0">
                 <a:solidFill>
                   <a:srgbClr val="A9B4C2"/>
                 </a:solidFill>
@@ -11130,7 +11151,7 @@
         <p:spPr>
           <a:xfrm>
             <a:off x="8292388" y="3374136"/>
-            <a:ext cx="2984906" cy="685800"/>
+            <a:ext cx="2984906" cy="731520"/>
           </a:xfrm>
           <a:prstGeom prst="rect">
             <a:avLst/>
@@ -11145,11 +11166,11 @@
           <a:p>
             <a:pPr algn="l">
               <a:lnSpc>
-                <a:spcPct val="115000"/>
-              </a:lnSpc>
-            </a:pPr>
-            <a:r>
-              <a:rPr sz="1250" b="0">
+                <a:spcPct val="112000"/>
+              </a:lnSpc>
+            </a:pPr>
+            <a:r>
+              <a:rPr sz="1150" b="0">
                 <a:solidFill>
                   <a:srgbClr val="A9B4C2"/>
                 </a:solidFill>
@@ -11759,8 +11780,8 @@
         </p:nvSpPr>
         <p:spPr>
           <a:xfrm>
-            <a:off x="731520" y="2423160"/>
-            <a:ext cx="2531287" cy="1691640"/>
+            <a:off x="731520" y="2377440"/>
+            <a:ext cx="2531287" cy="1828800"/>
           </a:xfrm>
           <a:prstGeom prst="roundRect">
             <a:avLst>
@@ -11807,8 +11828,8 @@
         </p:nvSpPr>
         <p:spPr>
           <a:xfrm>
-            <a:off x="731520" y="2423160"/>
-            <a:ext cx="54864" cy="1691640"/>
+            <a:off x="731520" y="2377440"/>
+            <a:ext cx="54864" cy="1828800"/>
           </a:xfrm>
           <a:prstGeom prst="rect">
             <a:avLst/>
@@ -11851,7 +11872,7 @@
         </p:nvSpPr>
         <p:spPr>
           <a:xfrm>
-            <a:off x="1005840" y="2624328"/>
+            <a:off x="1005840" y="2578608"/>
             <a:ext cx="2074087" cy="640080"/>
           </a:xfrm>
           <a:prstGeom prst="rect">
@@ -11890,8 +11911,8 @@
         </p:nvSpPr>
         <p:spPr>
           <a:xfrm>
-            <a:off x="1005840" y="3282696"/>
-            <a:ext cx="2074087" cy="777240"/>
+            <a:off x="1005840" y="3236976"/>
+            <a:ext cx="2074087" cy="960120"/>
           </a:xfrm>
           <a:prstGeom prst="rect">
             <a:avLst/>
@@ -11906,17 +11927,17 @@
           <a:p>
             <a:pPr algn="l">
               <a:lnSpc>
-                <a:spcPct val="115000"/>
-              </a:lnSpc>
-            </a:pPr>
-            <a:r>
-              <a:rPr sz="1250" b="0">
+                <a:spcPct val="112000"/>
+              </a:lnSpc>
+            </a:pPr>
+            <a:r>
+              <a:rPr sz="1150" b="0">
                 <a:solidFill>
                   <a:srgbClr val="A9B4C2"/>
                 </a:solidFill>
                 <a:latin typeface="DM Sans"/>
               </a:rPr>
-              <a:t>protocoles avec plus de 10 M$ d'actifs gérés, toutes chaînes (API DeFiLlama, 11/10/2026)</a:t>
+              <a:t>protocoles &gt; 10 M$ d'actifs gérés, toutes chaînes (API DeFiLlama, 11/10/2026)</a:t>
             </a:r>
           </a:p>
         </p:txBody>
@@ -11929,8 +11950,8 @@
         </p:nvSpPr>
         <p:spPr>
           <a:xfrm>
-            <a:off x="3463975" y="2423160"/>
-            <a:ext cx="2531287" cy="1691640"/>
+            <a:off x="3463975" y="2377440"/>
+            <a:ext cx="2531287" cy="1828800"/>
           </a:xfrm>
           <a:prstGeom prst="roundRect">
             <a:avLst>
@@ -11977,8 +11998,8 @@
         </p:nvSpPr>
         <p:spPr>
           <a:xfrm>
-            <a:off x="3463975" y="2423160"/>
-            <a:ext cx="54864" cy="1691640"/>
+            <a:off x="3463975" y="2377440"/>
+            <a:ext cx="54864" cy="1828800"/>
           </a:xfrm>
           <a:prstGeom prst="rect">
             <a:avLst/>
@@ -12021,7 +12042,7 @@
         </p:nvSpPr>
         <p:spPr>
           <a:xfrm>
-            <a:off x="3738295" y="2624328"/>
+            <a:off x="3738295" y="2578608"/>
             <a:ext cx="2074087" cy="640080"/>
           </a:xfrm>
           <a:prstGeom prst="rect">
@@ -12060,8 +12081,8 @@
         </p:nvSpPr>
         <p:spPr>
           <a:xfrm>
-            <a:off x="3738295" y="3282696"/>
-            <a:ext cx="2074087" cy="777240"/>
+            <a:off x="3738295" y="3236976"/>
+            <a:ext cx="2074087" cy="960120"/>
           </a:xfrm>
           <a:prstGeom prst="rect">
             <a:avLst/>
@@ -12076,11 +12097,11 @@
           <a:p>
             <a:pPr algn="l">
               <a:lnSpc>
-                <a:spcPct val="115000"/>
-              </a:lnSpc>
-            </a:pPr>
-            <a:r>
-              <a:rPr sz="1250" b="0">
+                <a:spcPct val="112000"/>
+              </a:lnSpc>
+            </a:pPr>
+            <a:r>
+              <a:rPr sz="1150" b="0">
                 <a:solidFill>
                   <a:srgbClr val="A9B4C2"/>
                 </a:solidFill>
@@ -12099,8 +12120,8 @@
         </p:nvSpPr>
         <p:spPr>
           <a:xfrm>
-            <a:off x="6196430" y="2423160"/>
-            <a:ext cx="2531287" cy="1691640"/>
+            <a:off x="6196430" y="2377440"/>
+            <a:ext cx="2531287" cy="1828800"/>
           </a:xfrm>
           <a:prstGeom prst="roundRect">
             <a:avLst>
@@ -12147,8 +12168,8 @@
         </p:nvSpPr>
         <p:spPr>
           <a:xfrm>
-            <a:off x="6196430" y="2423160"/>
-            <a:ext cx="54864" cy="1691640"/>
+            <a:off x="6196430" y="2377440"/>
+            <a:ext cx="54864" cy="1828800"/>
           </a:xfrm>
           <a:prstGeom prst="rect">
             <a:avLst/>
@@ -12191,7 +12212,7 @@
         </p:nvSpPr>
         <p:spPr>
           <a:xfrm>
-            <a:off x="6470750" y="2624328"/>
+            <a:off x="6470750" y="2578608"/>
             <a:ext cx="2074087" cy="640080"/>
           </a:xfrm>
           <a:prstGeom prst="rect">
@@ -12230,8 +12251,8 @@
         </p:nvSpPr>
         <p:spPr>
           <a:xfrm>
-            <a:off x="6470750" y="3282696"/>
-            <a:ext cx="2074087" cy="777240"/>
+            <a:off x="6470750" y="3236976"/>
+            <a:ext cx="2074087" cy="960120"/>
           </a:xfrm>
           <a:prstGeom prst="rect">
             <a:avLst/>
@@ -12246,17 +12267,17 @@
           <a:p>
             <a:pPr algn="l">
               <a:lnSpc>
-                <a:spcPct val="115000"/>
-              </a:lnSpc>
-            </a:pPr>
-            <a:r>
-              <a:rPr sz="1250" b="0">
+                <a:spcPct val="112000"/>
+              </a:lnSpc>
+            </a:pPr>
+            <a:r>
+              <a:rPr sz="1150" b="0">
                 <a:solidFill>
                   <a:srgbClr val="A9B4C2"/>
                 </a:solidFill>
                 <a:latin typeface="DM Sans"/>
               </a:rPr>
-              <a:t>organisations adressables sur Avalanche : 22 protocoles &gt; 10 M$, &gt; 50 L1, 10 équipes sur Safe</a:t>
+              <a:t>organisations adressables sur Avalanche (protocoles &gt; 10 M$, équipes de L1)</a:t>
             </a:r>
           </a:p>
         </p:txBody>
@@ -12269,8 +12290,8 @@
         </p:nvSpPr>
         <p:spPr>
           <a:xfrm>
-            <a:off x="8928885" y="2423160"/>
-            <a:ext cx="2531287" cy="1691640"/>
+            <a:off x="8928885" y="2377440"/>
+            <a:ext cx="2531287" cy="1828800"/>
           </a:xfrm>
           <a:prstGeom prst="roundRect">
             <a:avLst>
@@ -12317,8 +12338,8 @@
         </p:nvSpPr>
         <p:spPr>
           <a:xfrm>
-            <a:off x="8928885" y="2423160"/>
-            <a:ext cx="54864" cy="1691640"/>
+            <a:off x="8928885" y="2377440"/>
+            <a:ext cx="54864" cy="1828800"/>
           </a:xfrm>
           <a:prstGeom prst="rect">
             <a:avLst/>
@@ -12361,7 +12382,7 @@
         </p:nvSpPr>
         <p:spPr>
           <a:xfrm>
-            <a:off x="9203205" y="2624328"/>
+            <a:off x="9203205" y="2578608"/>
             <a:ext cx="2074087" cy="640080"/>
           </a:xfrm>
           <a:prstGeom prst="rect">
@@ -12400,8 +12421,8 @@
         </p:nvSpPr>
         <p:spPr>
           <a:xfrm>
-            <a:off x="9203205" y="3282696"/>
-            <a:ext cx="2074087" cy="777240"/>
+            <a:off x="9203205" y="3236976"/>
+            <a:ext cx="2074087" cy="960120"/>
           </a:xfrm>
           <a:prstGeom prst="rect">
             <a:avLst/>
@@ -12416,17 +12437,17 @@
           <a:p>
             <a:pPr algn="l">
               <a:lnSpc>
-                <a:spcPct val="115000"/>
-              </a:lnSpc>
-            </a:pPr>
-            <a:r>
-              <a:rPr sz="1250" b="0">
+                <a:spcPct val="112000"/>
+              </a:lnSpc>
+            </a:pPr>
+            <a:r>
+              <a:rPr sz="1150" b="0">
                 <a:solidFill>
                   <a:srgbClr val="A9B4C2"/>
                 </a:solidFill>
                 <a:latin typeface="DM Sans"/>
               </a:rPr>
-              <a:t>sur les chaînes EVM, borne basse : fonds et fondations exclus, faute de source</a:t>
+              <a:t>sur les chaînes EVM, borne basse (fonds et fondations exclus, faute de source)</a:t>
             </a:r>
           </a:p>
         </p:txBody>
@@ -12439,7 +12460,7 @@
         </p:nvSpPr>
         <p:spPr>
           <a:xfrm>
-            <a:off x="731520" y="4434840"/>
+            <a:off x="731520" y="4526280"/>
             <a:ext cx="10728655" cy="1005840"/>
           </a:xfrm>
           <a:prstGeom prst="rect">
@@ -14125,7 +14146,7 @@
                 </a:solidFill>
                 <a:latin typeface="DM Sans"/>
               </a:rPr>
-              <a:t>clé d'identité pour révoquer seul sa clé volée · clé de contrainte qui dit « oui » à l'écran et gèle en silence · probation des clés neuves.</a:t>
+              <a:t>clé d'identité pour révoquer seul sa clé volée · clé de contrainte qui gèle en silence · probation des clés neuves.</a:t>
             </a:r>
           </a:p>
         </p:txBody>
@@ -14182,7 +14203,7 @@
                 </a:solidFill>
                 <a:latin typeface="DM Sans"/>
               </a:rPr>
-              <a:t> (signature en plus, mise en attente : rien n'est jamais bloqué) · </a:t>
+              <a:t> (Essentiel, Standard : signature en plus, mise en attente ; rien n'est jamais bloqué) · </a:t>
             </a:r>
             <a:r>
               <a:rPr sz="1300" b="1">
@@ -14200,7 +14221,7 @@
                 </a:solidFill>
                 <a:latin typeface="DM Sans"/>
               </a:rPr>
-              <a:t> (un agent occupe un siège de signataire et refuse ; dérogation humaine après délai).</a:t>
+              <a:t> (Premium : un agent occupe un siège de signataire et refuse ; dérogation humaine après délai).</a:t>
             </a:r>
           </a:p>
         </p:txBody>
@@ -14888,7 +14909,7 @@
         <p:spPr>
           <a:xfrm>
             <a:off x="1005840" y="2962656"/>
-            <a:ext cx="2074087" cy="731520"/>
+            <a:ext cx="2074087" cy="777240"/>
           </a:xfrm>
           <a:prstGeom prst="rect">
             <a:avLst/>
@@ -14903,11 +14924,11 @@
           <a:p>
             <a:pPr algn="l">
               <a:lnSpc>
-                <a:spcPct val="115000"/>
-              </a:lnSpc>
-            </a:pPr>
-            <a:r>
-              <a:rPr sz="1250" b="0">
+                <a:spcPct val="112000"/>
+              </a:lnSpc>
+            </a:pPr>
+            <a:r>
+              <a:rPr sz="1150" b="0">
                 <a:solidFill>
                   <a:srgbClr val="A9B4C2"/>
                 </a:solidFill>
@@ -15058,7 +15079,7 @@
         <p:spPr>
           <a:xfrm>
             <a:off x="3738295" y="2962656"/>
-            <a:ext cx="2074087" cy="731520"/>
+            <a:ext cx="2074087" cy="777240"/>
           </a:xfrm>
           <a:prstGeom prst="rect">
             <a:avLst/>
@@ -15073,11 +15094,11 @@
           <a:p>
             <a:pPr algn="l">
               <a:lnSpc>
-                <a:spcPct val="115000"/>
-              </a:lnSpc>
-            </a:pPr>
-            <a:r>
-              <a:rPr sz="1250" b="0">
+                <a:spcPct val="112000"/>
+              </a:lnSpc>
+            </a:pPr>
+            <a:r>
+              <a:rPr sz="1150" b="0">
                 <a:solidFill>
                   <a:srgbClr val="A9B4C2"/>
                 </a:solidFill>
@@ -15228,7 +15249,7 @@
         <p:spPr>
           <a:xfrm>
             <a:off x="6470750" y="2962656"/>
-            <a:ext cx="2074087" cy="731520"/>
+            <a:ext cx="2074087" cy="777240"/>
           </a:xfrm>
           <a:prstGeom prst="rect">
             <a:avLst/>
@@ -15243,11 +15264,11 @@
           <a:p>
             <a:pPr algn="l">
               <a:lnSpc>
-                <a:spcPct val="115000"/>
-              </a:lnSpc>
-            </a:pPr>
-            <a:r>
-              <a:rPr sz="1250" b="0">
+                <a:spcPct val="112000"/>
+              </a:lnSpc>
+            </a:pPr>
+            <a:r>
+              <a:rPr sz="1150" b="0">
                 <a:solidFill>
                   <a:srgbClr val="A9B4C2"/>
                 </a:solidFill>
@@ -15398,7 +15419,7 @@
         <p:spPr>
           <a:xfrm>
             <a:off x="9203205" y="2962656"/>
-            <a:ext cx="2074087" cy="731520"/>
+            <a:ext cx="2074087" cy="777240"/>
           </a:xfrm>
           <a:prstGeom prst="rect">
             <a:avLst/>
@@ -15413,11 +15434,11 @@
           <a:p>
             <a:pPr algn="l">
               <a:lnSpc>
-                <a:spcPct val="115000"/>
-              </a:lnSpc>
-            </a:pPr>
-            <a:r>
-              <a:rPr sz="1250" b="0">
+                <a:spcPct val="112000"/>
+              </a:lnSpc>
+            </a:pPr>
+            <a:r>
+              <a:rPr sz="1150" b="0">
                 <a:solidFill>
                   <a:srgbClr val="A9B4C2"/>
                 </a:solidFill>
@@ -15568,7 +15589,7 @@
         <p:spPr>
           <a:xfrm>
             <a:off x="1005840" y="4837175"/>
-            <a:ext cx="2984906" cy="548640"/>
+            <a:ext cx="2984906" cy="594360"/>
           </a:xfrm>
           <a:prstGeom prst="rect">
             <a:avLst/>
@@ -15583,11 +15604,11 @@
           <a:p>
             <a:pPr algn="l">
               <a:lnSpc>
-                <a:spcPct val="115000"/>
-              </a:lnSpc>
-            </a:pPr>
-            <a:r>
-              <a:rPr sz="1250" b="0">
+                <a:spcPct val="112000"/>
+              </a:lnSpc>
+            </a:pPr>
+            <a:r>
+              <a:rPr sz="1150" b="0">
                 <a:solidFill>
                   <a:srgbClr val="A9B4C2"/>
                 </a:solidFill>
@@ -15738,7 +15759,7 @@
         <p:spPr>
           <a:xfrm>
             <a:off x="4649114" y="4837175"/>
-            <a:ext cx="2984906" cy="548640"/>
+            <a:ext cx="2984906" cy="594360"/>
           </a:xfrm>
           <a:prstGeom prst="rect">
             <a:avLst/>
@@ -15753,11 +15774,11 @@
           <a:p>
             <a:pPr algn="l">
               <a:lnSpc>
-                <a:spcPct val="115000"/>
-              </a:lnSpc>
-            </a:pPr>
-            <a:r>
-              <a:rPr sz="1250" b="0">
+                <a:spcPct val="112000"/>
+              </a:lnSpc>
+            </a:pPr>
+            <a:r>
+              <a:rPr sz="1150" b="0">
                 <a:solidFill>
                   <a:srgbClr val="A9B4C2"/>
                 </a:solidFill>
@@ -15908,7 +15929,7 @@
         <p:spPr>
           <a:xfrm>
             <a:off x="8292388" y="4837175"/>
-            <a:ext cx="2984906" cy="548640"/>
+            <a:ext cx="2984906" cy="594360"/>
           </a:xfrm>
           <a:prstGeom prst="rect">
             <a:avLst/>
@@ -15923,11 +15944,11 @@
           <a:p>
             <a:pPr algn="l">
               <a:lnSpc>
-                <a:spcPct val="115000"/>
-              </a:lnSpc>
-            </a:pPr>
-            <a:r>
-              <a:rPr sz="1250" b="0">
+                <a:spcPct val="112000"/>
+              </a:lnSpc>
+            </a:pPr>
+            <a:r>
+              <a:rPr sz="1150" b="0">
                 <a:solidFill>
                   <a:srgbClr val="A9B4C2"/>
                 </a:solidFill>
@@ -16350,7 +16371,7 @@
                 </a:solidFill>
                 <a:latin typeface="DM Sans"/>
               </a:rPr>
-              <a:t>Safe Pro vend des règles que vous écrivez ; nous détectons ce que vous n'avez pas prévu</a:t>
+              <a:t>une gradation, une offre : une personne de plus, du temps, un refus</a:t>
             </a:r>
           </a:p>
         </p:txBody>
@@ -16476,7 +16497,7 @@
                 </a:solidFill>
                 <a:latin typeface="Manrope"/>
               </a:rPr>
-              <a:t>Un prix affiché, selon la taille de votre trésorerie</a:t>
+              <a:t>Un prix affiché, selon le pouvoir que vous déléguez</a:t>
             </a:r>
           </a:p>
         </p:txBody>
@@ -16489,12 +16510,12 @@
         </p:nvSpPr>
         <p:spPr>
           <a:xfrm>
-            <a:off x="731520" y="2194560"/>
-            <a:ext cx="2545003" cy="1965960"/>
+            <a:off x="731520" y="2103120"/>
+            <a:ext cx="2545003" cy="2514600"/>
           </a:xfrm>
           <a:prstGeom prst="roundRect">
             <a:avLst>
-              <a:gd name="adj" fmla="val 8000"/>
+              <a:gd name="adj" fmla="val 6000"/>
             </a:avLst>
           </a:prstGeom>
           <a:solidFill>
@@ -16531,13 +16552,144 @@
       </p:sp>
       <p:sp>
         <p:nvSpPr>
-          <p:cNvPr id="14" name="TextBox 13"/>
-          <p:cNvSpPr txBox="1"/>
-          <p:nvPr/>
-        </p:nvSpPr>
-        <p:spPr>
-          <a:xfrm>
-            <a:off x="1005840" y="2395728"/>
+          <p:cNvPr id="14" name="Rectangle 13"/>
+          <p:cNvSpPr/>
+          <p:nvPr/>
+        </p:nvSpPr>
+        <p:spPr>
+          <a:xfrm>
+            <a:off x="731520" y="2103120"/>
+            <a:ext cx="54864" cy="2514600"/>
+          </a:xfrm>
+          <a:prstGeom prst="rect">
+            <a:avLst/>
+          </a:prstGeom>
+          <a:solidFill>
+            <a:srgbClr val="F6F9FC"/>
+          </a:solidFill>
+          <a:ln>
+            <a:noFill/>
+          </a:ln>
+          <a:effectLst/>
+        </p:spPr>
+        <p:style>
+          <a:lnRef idx="1">
+            <a:schemeClr val="accent1"/>
+          </a:lnRef>
+          <a:fillRef idx="3">
+            <a:schemeClr val="accent1"/>
+          </a:fillRef>
+          <a:effectRef idx="2">
+            <a:schemeClr val="accent1"/>
+          </a:effectRef>
+          <a:fontRef idx="minor">
+            <a:schemeClr val="lt1"/>
+          </a:fontRef>
+        </p:style>
+        <p:txBody>
+          <a:bodyPr rtlCol="0" anchor="ctr"/>
+          <a:lstStyle/>
+          <a:p>
+            <a:pPr algn="ctr"/>
+          </a:p>
+        </p:txBody>
+      </p:sp>
+      <p:sp>
+        <p:nvSpPr>
+          <p:cNvPr id="15" name="TextBox 14"/>
+          <p:cNvSpPr txBox="1"/>
+          <p:nvPr/>
+        </p:nvSpPr>
+        <p:spPr>
+          <a:xfrm>
+            <a:off x="1005840" y="2286000"/>
+            <a:ext cx="2087803" cy="320040"/>
+          </a:xfrm>
+          <a:prstGeom prst="rect">
+            <a:avLst/>
+          </a:prstGeom>
+          <a:noFill/>
+        </p:spPr>
+        <p:txBody>
+          <a:bodyPr wrap="square" anchor="t" lIns="0" rIns="0" tIns="0" bIns="0">
+            <a:spAutoFit/>
+          </a:bodyPr>
+          <a:lstStyle/>
+          <a:p>
+            <a:pPr algn="l">
+              <a:lnSpc>
+                <a:spcPct val="115000"/>
+              </a:lnSpc>
+            </a:pPr>
+            <a:r>
+              <a:rPr sz="1250" b="1">
+                <a:solidFill>
+                  <a:srgbClr val="A9B4C2"/>
+                </a:solidFill>
+                <a:latin typeface="DM Sans"/>
+              </a:rPr>
+              <a:t>Observation</a:t>
+            </a:r>
+          </a:p>
+        </p:txBody>
+      </p:sp>
+      <p:sp>
+        <p:nvSpPr>
+          <p:cNvPr id="16" name="TextBox 15"/>
+          <p:cNvSpPr txBox="1"/>
+          <p:nvPr/>
+        </p:nvSpPr>
+        <p:spPr>
+          <a:xfrm>
+            <a:off x="1005840" y="2560320"/>
+            <a:ext cx="2087803" cy="548640"/>
+          </a:xfrm>
+          <a:prstGeom prst="rect">
+            <a:avLst/>
+          </a:prstGeom>
+          <a:noFill/>
+        </p:spPr>
+        <p:txBody>
+          <a:bodyPr wrap="square" anchor="t" lIns="0" rIns="0" tIns="0" bIns="0">
+            <a:spAutoFit/>
+          </a:bodyPr>
+          <a:lstStyle/>
+          <a:p>
+            <a:pPr algn="l">
+              <a:lnSpc>
+                <a:spcPct val="115000"/>
+              </a:lnSpc>
+            </a:pPr>
+            <a:r>
+              <a:rPr sz="3000" b="1">
+                <a:solidFill>
+                  <a:srgbClr val="F6F9FC"/>
+                </a:solidFill>
+                <a:latin typeface="Manrope"/>
+              </a:rPr>
+              <a:t>0 €</a:t>
+            </a:r>
+            <a:r>
+              <a:rPr sz="1100" b="0">
+                <a:solidFill>
+                  <a:srgbClr val="7F8B9B"/>
+                </a:solidFill>
+                <a:latin typeface="DM Sans"/>
+              </a:rPr>
+              <a:t>  30 jours</a:t>
+            </a:r>
+          </a:p>
+        </p:txBody>
+      </p:sp>
+      <p:sp>
+        <p:nvSpPr>
+          <p:cNvPr id="17" name="TextBox 16"/>
+          <p:cNvSpPr txBox="1"/>
+          <p:nvPr/>
+        </p:nvSpPr>
+        <p:spPr>
+          <a:xfrm>
+            <a:off x="1005840" y="3154680"/>
             <a:ext cx="2087803" cy="365760"/>
           </a:xfrm>
           <a:prstGeom prst="rect">
@@ -16557,118 +16709,70 @@
               </a:lnSpc>
             </a:pPr>
             <a:r>
-              <a:rPr sz="1300" b="1">
+              <a:rPr sz="1500" b="1">
+                <a:solidFill>
+                  <a:srgbClr val="F6F9FC"/>
+                </a:solidFill>
+                <a:latin typeface="Manrope"/>
+              </a:rPr>
+              <a:t>Regarde, explique</a:t>
+            </a:r>
+          </a:p>
+        </p:txBody>
+      </p:sp>
+      <p:sp>
+        <p:nvSpPr>
+          <p:cNvPr id="18" name="TextBox 17"/>
+          <p:cNvSpPr txBox="1"/>
+          <p:nvPr/>
+        </p:nvSpPr>
+        <p:spPr>
+          <a:xfrm>
+            <a:off x="1005840" y="3520440"/>
+            <a:ext cx="2087803" cy="1005840"/>
+          </a:xfrm>
+          <a:prstGeom prst="rect">
+            <a:avLst/>
+          </a:prstGeom>
+          <a:noFill/>
+        </p:spPr>
+        <p:txBody>
+          <a:bodyPr wrap="square" anchor="t" lIns="0" rIns="0" tIns="0" bIns="0">
+            <a:spAutoFit/>
+          </a:bodyPr>
+          <a:lstStyle/>
+          <a:p>
+            <a:pPr algn="l">
+              <a:lnSpc>
+                <a:spcPct val="112000"/>
+              </a:lnSpc>
+            </a:pPr>
+            <a:r>
+              <a:rPr sz="1050" b="0">
                 <a:solidFill>
                   <a:srgbClr val="A9B4C2"/>
                 </a:solidFill>
                 <a:latin typeface="DM Sans"/>
               </a:rPr>
-              <a:t>Observation</a:t>
-            </a:r>
-          </a:p>
-        </p:txBody>
-      </p:sp>
-      <p:sp>
-        <p:nvSpPr>
-          <p:cNvPr id="15" name="TextBox 14"/>
-          <p:cNvSpPr txBox="1"/>
-          <p:nvPr/>
-        </p:nvSpPr>
-        <p:spPr>
-          <a:xfrm>
-            <a:off x="1005840" y="2743200"/>
-            <a:ext cx="2087803" cy="640080"/>
-          </a:xfrm>
-          <a:prstGeom prst="rect">
-            <a:avLst/>
-          </a:prstGeom>
-          <a:noFill/>
-        </p:spPr>
-        <p:txBody>
-          <a:bodyPr wrap="square" anchor="t" lIns="0" rIns="0" tIns="0" bIns="0">
-            <a:spAutoFit/>
-          </a:bodyPr>
-          <a:lstStyle/>
-          <a:p>
-            <a:pPr algn="l">
-              <a:lnSpc>
-                <a:spcPct val="115000"/>
-              </a:lnSpc>
-            </a:pPr>
-            <a:r>
-              <a:rPr sz="3400" b="1">
-                <a:solidFill>
-                  <a:srgbClr val="F6F9FC"/>
-                </a:solidFill>
-                <a:latin typeface="Manrope"/>
-              </a:rPr>
-              <a:t>0 €</a:t>
-            </a:r>
-            <a:r>
-              <a:rPr sz="1200" b="0">
-                <a:solidFill>
-                  <a:srgbClr val="7F8B9B"/>
-                </a:solidFill>
-                <a:latin typeface="DM Sans"/>
-              </a:rPr>
-              <a:t>  30 jours</a:t>
-            </a:r>
-          </a:p>
-        </p:txBody>
-      </p:sp>
-      <p:sp>
-        <p:nvSpPr>
-          <p:cNvPr id="16" name="TextBox 15"/>
-          <p:cNvSpPr txBox="1"/>
-          <p:nvPr/>
-        </p:nvSpPr>
-        <p:spPr>
-          <a:xfrm>
-            <a:off x="1005840" y="3383280"/>
-            <a:ext cx="2087803" cy="640080"/>
-          </a:xfrm>
-          <a:prstGeom prst="rect">
-            <a:avLst/>
-          </a:prstGeom>
-          <a:noFill/>
-        </p:spPr>
-        <p:txBody>
-          <a:bodyPr wrap="square" anchor="t" lIns="0" rIns="0" tIns="0" bIns="0">
-            <a:spAutoFit/>
-          </a:bodyPr>
-          <a:lstStyle/>
-          <a:p>
-            <a:pPr algn="l">
-              <a:lnSpc>
-                <a:spcPct val="115000"/>
-              </a:lnSpc>
-            </a:pPr>
-            <a:r>
-              <a:rPr sz="1150" b="0">
-                <a:solidFill>
-                  <a:srgbClr val="A9B4C2"/>
-                </a:solidFill>
-                <a:latin typeface="DM Sans"/>
-              </a:rPr>
-              <a:t>détection et explications en lecture seule, rapport de fin d'observation</a:t>
-            </a:r>
-          </a:p>
-        </p:txBody>
-      </p:sp>
-      <p:sp>
-        <p:nvSpPr>
-          <p:cNvPr id="17" name="Rounded Rectangle 16"/>
+              <a:t>rien ne change à vos paiements · alertes et explications en lecture seule · rapport de fin d'observation</a:t>
+            </a:r>
+          </a:p>
+        </p:txBody>
+      </p:sp>
+      <p:sp>
+        <p:nvSpPr>
+          <p:cNvPr id="19" name="Rounded Rectangle 18"/>
           <p:cNvSpPr/>
           <p:nvPr/>
         </p:nvSpPr>
         <p:spPr>
           <a:xfrm>
-            <a:off x="3459403" y="2194560"/>
-            <a:ext cx="2545003" cy="1965960"/>
+            <a:off x="3459403" y="2103120"/>
+            <a:ext cx="2545003" cy="2514600"/>
           </a:xfrm>
           <a:prstGeom prst="roundRect">
             <a:avLst>
-              <a:gd name="adj" fmla="val 8000"/>
+              <a:gd name="adj" fmla="val 6000"/>
             </a:avLst>
           </a:prstGeom>
           <a:solidFill>
@@ -16705,13 +16809,144 @@
       </p:sp>
       <p:sp>
         <p:nvSpPr>
-          <p:cNvPr id="18" name="TextBox 17"/>
-          <p:cNvSpPr txBox="1"/>
-          <p:nvPr/>
-        </p:nvSpPr>
-        <p:spPr>
-          <a:xfrm>
-            <a:off x="3733723" y="2395728"/>
+          <p:cNvPr id="20" name="Rectangle 19"/>
+          <p:cNvSpPr/>
+          <p:nvPr/>
+        </p:nvSpPr>
+        <p:spPr>
+          <a:xfrm>
+            <a:off x="3459403" y="2103120"/>
+            <a:ext cx="54864" cy="2514600"/>
+          </a:xfrm>
+          <a:prstGeom prst="rect">
+            <a:avLst/>
+          </a:prstGeom>
+          <a:solidFill>
+            <a:srgbClr val="A8BFFF"/>
+          </a:solidFill>
+          <a:ln>
+            <a:noFill/>
+          </a:ln>
+          <a:effectLst/>
+        </p:spPr>
+        <p:style>
+          <a:lnRef idx="1">
+            <a:schemeClr val="accent1"/>
+          </a:lnRef>
+          <a:fillRef idx="3">
+            <a:schemeClr val="accent1"/>
+          </a:fillRef>
+          <a:effectRef idx="2">
+            <a:schemeClr val="accent1"/>
+          </a:effectRef>
+          <a:fontRef idx="minor">
+            <a:schemeClr val="lt1"/>
+          </a:fontRef>
+        </p:style>
+        <p:txBody>
+          <a:bodyPr rtlCol="0" anchor="ctr"/>
+          <a:lstStyle/>
+          <a:p>
+            <a:pPr algn="ctr"/>
+          </a:p>
+        </p:txBody>
+      </p:sp>
+      <p:sp>
+        <p:nvSpPr>
+          <p:cNvPr id="21" name="TextBox 20"/>
+          <p:cNvSpPr txBox="1"/>
+          <p:nvPr/>
+        </p:nvSpPr>
+        <p:spPr>
+          <a:xfrm>
+            <a:off x="3733723" y="2286000"/>
+            <a:ext cx="2087803" cy="320040"/>
+          </a:xfrm>
+          <a:prstGeom prst="rect">
+            <a:avLst/>
+          </a:prstGeom>
+          <a:noFill/>
+        </p:spPr>
+        <p:txBody>
+          <a:bodyPr wrap="square" anchor="t" lIns="0" rIns="0" tIns="0" bIns="0">
+            <a:spAutoFit/>
+          </a:bodyPr>
+          <a:lstStyle/>
+          <a:p>
+            <a:pPr algn="l">
+              <a:lnSpc>
+                <a:spcPct val="115000"/>
+              </a:lnSpc>
+            </a:pPr>
+            <a:r>
+              <a:rPr sz="1250" b="1">
+                <a:solidFill>
+                  <a:srgbClr val="A9B4C2"/>
+                </a:solidFill>
+                <a:latin typeface="DM Sans"/>
+              </a:rPr>
+              <a:t>Essentiel</a:t>
+            </a:r>
+          </a:p>
+        </p:txBody>
+      </p:sp>
+      <p:sp>
+        <p:nvSpPr>
+          <p:cNvPr id="22" name="TextBox 21"/>
+          <p:cNvSpPr txBox="1"/>
+          <p:nvPr/>
+        </p:nvSpPr>
+        <p:spPr>
+          <a:xfrm>
+            <a:off x="3733723" y="2560320"/>
+            <a:ext cx="2087803" cy="548640"/>
+          </a:xfrm>
+          <a:prstGeom prst="rect">
+            <a:avLst/>
+          </a:prstGeom>
+          <a:noFill/>
+        </p:spPr>
+        <p:txBody>
+          <a:bodyPr wrap="square" anchor="t" lIns="0" rIns="0" tIns="0" bIns="0">
+            <a:spAutoFit/>
+          </a:bodyPr>
+          <a:lstStyle/>
+          <a:p>
+            <a:pPr algn="l">
+              <a:lnSpc>
+                <a:spcPct val="115000"/>
+              </a:lnSpc>
+            </a:pPr>
+            <a:r>
+              <a:rPr sz="3000" b="1">
+                <a:solidFill>
+                  <a:srgbClr val="F6F9FC"/>
+                </a:solidFill>
+                <a:latin typeface="Manrope"/>
+              </a:rPr>
+              <a:t>149 €</a:t>
+            </a:r>
+            <a:r>
+              <a:rPr sz="1100" b="0">
+                <a:solidFill>
+                  <a:srgbClr val="7F8B9B"/>
+                </a:solidFill>
+                <a:latin typeface="DM Sans"/>
+              </a:rPr>
+              <a:t>  / mois</a:t>
+            </a:r>
+          </a:p>
+        </p:txBody>
+      </p:sp>
+      <p:sp>
+        <p:nvSpPr>
+          <p:cNvPr id="23" name="TextBox 22"/>
+          <p:cNvSpPr txBox="1"/>
+          <p:nvPr/>
+        </p:nvSpPr>
+        <p:spPr>
+          <a:xfrm>
+            <a:off x="3733723" y="3154680"/>
             <a:ext cx="2087803" cy="365760"/>
           </a:xfrm>
           <a:prstGeom prst="rect">
@@ -16731,118 +16966,70 @@
               </a:lnSpc>
             </a:pPr>
             <a:r>
-              <a:rPr sz="1300" b="1">
+              <a:rPr sz="1500" b="1">
+                <a:solidFill>
+                  <a:srgbClr val="A8BFFF"/>
+                </a:solidFill>
+                <a:latin typeface="Manrope"/>
+              </a:rPr>
+              <a:t>+ une personne</a:t>
+            </a:r>
+          </a:p>
+        </p:txBody>
+      </p:sp>
+      <p:sp>
+        <p:nvSpPr>
+          <p:cNvPr id="24" name="TextBox 23"/>
+          <p:cNvSpPr txBox="1"/>
+          <p:nvPr/>
+        </p:nvSpPr>
+        <p:spPr>
+          <a:xfrm>
+            <a:off x="3733723" y="3520440"/>
+            <a:ext cx="2087803" cy="1005840"/>
+          </a:xfrm>
+          <a:prstGeom prst="rect">
+            <a:avLst/>
+          </a:prstGeom>
+          <a:noFill/>
+        </p:spPr>
+        <p:txBody>
+          <a:bodyPr wrap="square" anchor="t" lIns="0" rIns="0" tIns="0" bIns="0">
+            <a:spAutoFit/>
+          </a:bodyPr>
+          <a:lstStyle/>
+          <a:p>
+            <a:pPr algn="l">
+              <a:lnSpc>
+                <a:spcPct val="112000"/>
+              </a:lnSpc>
+            </a:pPr>
+            <a:r>
+              <a:rPr sz="1050" b="0">
                 <a:solidFill>
                   <a:srgbClr val="A9B4C2"/>
                 </a:solidFill>
                 <a:latin typeface="DM Sans"/>
               </a:rPr>
-              <a:t>Essentiel</a:t>
-            </a:r>
-          </a:p>
-        </p:txBody>
-      </p:sp>
-      <p:sp>
-        <p:nvSpPr>
-          <p:cNvPr id="19" name="TextBox 18"/>
-          <p:cNvSpPr txBox="1"/>
-          <p:nvPr/>
-        </p:nvSpPr>
-        <p:spPr>
-          <a:xfrm>
-            <a:off x="3733723" y="2743200"/>
-            <a:ext cx="2087803" cy="640080"/>
-          </a:xfrm>
-          <a:prstGeom prst="rect">
-            <a:avLst/>
-          </a:prstGeom>
-          <a:noFill/>
-        </p:spPr>
-        <p:txBody>
-          <a:bodyPr wrap="square" anchor="t" lIns="0" rIns="0" tIns="0" bIns="0">
-            <a:spAutoFit/>
-          </a:bodyPr>
-          <a:lstStyle/>
-          <a:p>
-            <a:pPr algn="l">
-              <a:lnSpc>
-                <a:spcPct val="115000"/>
-              </a:lnSpc>
-            </a:pPr>
-            <a:r>
-              <a:rPr sz="3400" b="1">
-                <a:solidFill>
-                  <a:srgbClr val="F6F9FC"/>
-                </a:solidFill>
-                <a:latin typeface="Manrope"/>
-              </a:rPr>
-              <a:t>149 €</a:t>
-            </a:r>
-            <a:r>
-              <a:rPr sz="1200" b="0">
-                <a:solidFill>
-                  <a:srgbClr val="7F8B9B"/>
-                </a:solidFill>
-                <a:latin typeface="DM Sans"/>
-              </a:rPr>
-              <a:t>  / mois</a:t>
-            </a:r>
-          </a:p>
-        </p:txBody>
-      </p:sp>
-      <p:sp>
-        <p:nvSpPr>
-          <p:cNvPr id="20" name="TextBox 19"/>
-          <p:cNvSpPr txBox="1"/>
-          <p:nvPr/>
-        </p:nvSpPr>
-        <p:spPr>
-          <a:xfrm>
-            <a:off x="3733723" y="3383280"/>
-            <a:ext cx="2087803" cy="640080"/>
-          </a:xfrm>
-          <a:prstGeom prst="rect">
-            <a:avLst/>
-          </a:prstGeom>
-          <a:noFill/>
-        </p:spPr>
-        <p:txBody>
-          <a:bodyPr wrap="square" anchor="t" lIns="0" rIns="0" tIns="0" bIns="0">
-            <a:spAutoFit/>
-          </a:bodyPr>
-          <a:lstStyle/>
-          <a:p>
-            <a:pPr algn="l">
-              <a:lnSpc>
-                <a:spcPct val="115000"/>
-              </a:lnSpc>
-            </a:pPr>
-            <a:r>
-              <a:rPr sz="1150" b="0">
-                <a:solidFill>
-                  <a:srgbClr val="A9B4C2"/>
-                </a:solidFill>
-                <a:latin typeface="DM Sans"/>
-              </a:rPr>
-              <a:t>&lt; 1 M$ · friction, explications, listes publiques, notifications</a:t>
-            </a:r>
-          </a:p>
-        </p:txBody>
-      </p:sp>
-      <p:sp>
-        <p:nvSpPr>
-          <p:cNvPr id="21" name="Rounded Rectangle 20"/>
+              <a:t>signature en plus sur les paiements inhabituels · explications en français · listes OFAC / ScamSniffer · notifications</a:t>
+            </a:r>
+          </a:p>
+        </p:txBody>
+      </p:sp>
+      <p:sp>
+        <p:nvSpPr>
+          <p:cNvPr id="25" name="Rounded Rectangle 24"/>
           <p:cNvSpPr/>
           <p:nvPr/>
         </p:nvSpPr>
         <p:spPr>
           <a:xfrm>
-            <a:off x="6187286" y="2194560"/>
-            <a:ext cx="2545003" cy="1965960"/>
+            <a:off x="6187286" y="2103120"/>
+            <a:ext cx="2545003" cy="2514600"/>
           </a:xfrm>
           <a:prstGeom prst="roundRect">
             <a:avLst>
-              <a:gd name="adj" fmla="val 8000"/>
+              <a:gd name="adj" fmla="val 6000"/>
             </a:avLst>
           </a:prstGeom>
           <a:solidFill>
@@ -16879,13 +17066,144 @@
       </p:sp>
       <p:sp>
         <p:nvSpPr>
-          <p:cNvPr id="22" name="TextBox 21"/>
-          <p:cNvSpPr txBox="1"/>
-          <p:nvPr/>
-        </p:nvSpPr>
-        <p:spPr>
-          <a:xfrm>
-            <a:off x="6461606" y="2395728"/>
+          <p:cNvPr id="26" name="Rectangle 25"/>
+          <p:cNvSpPr/>
+          <p:nvPr/>
+        </p:nvSpPr>
+        <p:spPr>
+          <a:xfrm>
+            <a:off x="6187286" y="2103120"/>
+            <a:ext cx="54864" cy="2514600"/>
+          </a:xfrm>
+          <a:prstGeom prst="rect">
+            <a:avLst/>
+          </a:prstGeom>
+          <a:solidFill>
+            <a:srgbClr val="FFC481"/>
+          </a:solidFill>
+          <a:ln>
+            <a:noFill/>
+          </a:ln>
+          <a:effectLst/>
+        </p:spPr>
+        <p:style>
+          <a:lnRef idx="1">
+            <a:schemeClr val="accent1"/>
+          </a:lnRef>
+          <a:fillRef idx="3">
+            <a:schemeClr val="accent1"/>
+          </a:fillRef>
+          <a:effectRef idx="2">
+            <a:schemeClr val="accent1"/>
+          </a:effectRef>
+          <a:fontRef idx="minor">
+            <a:schemeClr val="lt1"/>
+          </a:fontRef>
+        </p:style>
+        <p:txBody>
+          <a:bodyPr rtlCol="0" anchor="ctr"/>
+          <a:lstStyle/>
+          <a:p>
+            <a:pPr algn="ctr"/>
+          </a:p>
+        </p:txBody>
+      </p:sp>
+      <p:sp>
+        <p:nvSpPr>
+          <p:cNvPr id="27" name="TextBox 26"/>
+          <p:cNvSpPr txBox="1"/>
+          <p:nvPr/>
+        </p:nvSpPr>
+        <p:spPr>
+          <a:xfrm>
+            <a:off x="6461606" y="2286000"/>
+            <a:ext cx="2087803" cy="320040"/>
+          </a:xfrm>
+          <a:prstGeom prst="rect">
+            <a:avLst/>
+          </a:prstGeom>
+          <a:noFill/>
+        </p:spPr>
+        <p:txBody>
+          <a:bodyPr wrap="square" anchor="t" lIns="0" rIns="0" tIns="0" bIns="0">
+            <a:spAutoFit/>
+          </a:bodyPr>
+          <a:lstStyle/>
+          <a:p>
+            <a:pPr algn="l">
+              <a:lnSpc>
+                <a:spcPct val="115000"/>
+              </a:lnSpc>
+            </a:pPr>
+            <a:r>
+              <a:rPr sz="1250" b="1">
+                <a:solidFill>
+                  <a:srgbClr val="A9B4C2"/>
+                </a:solidFill>
+                <a:latin typeface="DM Sans"/>
+              </a:rPr>
+              <a:t>Standard</a:t>
+            </a:r>
+          </a:p>
+        </p:txBody>
+      </p:sp>
+      <p:sp>
+        <p:nvSpPr>
+          <p:cNvPr id="28" name="TextBox 27"/>
+          <p:cNvSpPr txBox="1"/>
+          <p:nvPr/>
+        </p:nvSpPr>
+        <p:spPr>
+          <a:xfrm>
+            <a:off x="6461606" y="2560320"/>
+            <a:ext cx="2087803" cy="548640"/>
+          </a:xfrm>
+          <a:prstGeom prst="rect">
+            <a:avLst/>
+          </a:prstGeom>
+          <a:noFill/>
+        </p:spPr>
+        <p:txBody>
+          <a:bodyPr wrap="square" anchor="t" lIns="0" rIns="0" tIns="0" bIns="0">
+            <a:spAutoFit/>
+          </a:bodyPr>
+          <a:lstStyle/>
+          <a:p>
+            <a:pPr algn="l">
+              <a:lnSpc>
+                <a:spcPct val="115000"/>
+              </a:lnSpc>
+            </a:pPr>
+            <a:r>
+              <a:rPr sz="3000" b="1">
+                <a:solidFill>
+                  <a:srgbClr val="F6F9FC"/>
+                </a:solidFill>
+                <a:latin typeface="Manrope"/>
+              </a:rPr>
+              <a:t>449 €</a:t>
+            </a:r>
+            <a:r>
+              <a:rPr sz="1100" b="0">
+                <a:solidFill>
+                  <a:srgbClr val="7F8B9B"/>
+                </a:solidFill>
+                <a:latin typeface="DM Sans"/>
+              </a:rPr>
+              <a:t>  / mois</a:t>
+            </a:r>
+          </a:p>
+        </p:txBody>
+      </p:sp>
+      <p:sp>
+        <p:nvSpPr>
+          <p:cNvPr id="29" name="TextBox 28"/>
+          <p:cNvSpPr txBox="1"/>
+          <p:nvPr/>
+        </p:nvSpPr>
+        <p:spPr>
+          <a:xfrm>
+            <a:off x="6461606" y="3154680"/>
             <a:ext cx="2087803" cy="365760"/>
           </a:xfrm>
           <a:prstGeom prst="rect">
@@ -16905,118 +17223,70 @@
               </a:lnSpc>
             </a:pPr>
             <a:r>
-              <a:rPr sz="1300" b="1">
-                <a:solidFill>
-                  <a:srgbClr val="C7FA70"/>
+              <a:rPr sz="1500" b="1">
+                <a:solidFill>
+                  <a:srgbClr val="FFC481"/>
+                </a:solidFill>
+                <a:latin typeface="Manrope"/>
+              </a:rPr>
+              <a:t>+ du temps</a:t>
+            </a:r>
+          </a:p>
+        </p:txBody>
+      </p:sp>
+      <p:sp>
+        <p:nvSpPr>
+          <p:cNvPr id="30" name="TextBox 29"/>
+          <p:cNvSpPr txBox="1"/>
+          <p:nvPr/>
+        </p:nvSpPr>
+        <p:spPr>
+          <a:xfrm>
+            <a:off x="6461606" y="3520440"/>
+            <a:ext cx="2087803" cy="1005840"/>
+          </a:xfrm>
+          <a:prstGeom prst="rect">
+            <a:avLst/>
+          </a:prstGeom>
+          <a:noFill/>
+        </p:spPr>
+        <p:txBody>
+          <a:bodyPr wrap="square" anchor="t" lIns="0" rIns="0" tIns="0" bIns="0">
+            <a:spAutoFit/>
+          </a:bodyPr>
+          <a:lstStyle/>
+          <a:p>
+            <a:pPr algn="l">
+              <a:lnSpc>
+                <a:spcPct val="112000"/>
+              </a:lnSpc>
+            </a:pPr>
+            <a:r>
+              <a:rPr sz="1050" b="0">
+                <a:solidFill>
+                  <a:srgbClr val="A9B4C2"/>
                 </a:solidFill>
                 <a:latin typeface="DM Sans"/>
               </a:rPr>
-              <a:t>Standard</a:t>
-            </a:r>
-          </a:p>
-        </p:txBody>
-      </p:sp>
-      <p:sp>
-        <p:nvSpPr>
-          <p:cNvPr id="23" name="TextBox 22"/>
-          <p:cNvSpPr txBox="1"/>
-          <p:nvPr/>
-        </p:nvSpPr>
-        <p:spPr>
-          <a:xfrm>
-            <a:off x="6461606" y="2743200"/>
-            <a:ext cx="2087803" cy="640080"/>
-          </a:xfrm>
-          <a:prstGeom prst="rect">
-            <a:avLst/>
-          </a:prstGeom>
-          <a:noFill/>
-        </p:spPr>
-        <p:txBody>
-          <a:bodyPr wrap="square" anchor="t" lIns="0" rIns="0" tIns="0" bIns="0">
-            <a:spAutoFit/>
-          </a:bodyPr>
-          <a:lstStyle/>
-          <a:p>
-            <a:pPr algn="l">
-              <a:lnSpc>
-                <a:spcPct val="115000"/>
-              </a:lnSpc>
-            </a:pPr>
-            <a:r>
-              <a:rPr sz="3400" b="1">
-                <a:solidFill>
-                  <a:srgbClr val="F6F9FC"/>
-                </a:solidFill>
-                <a:latin typeface="Manrope"/>
-              </a:rPr>
-              <a:t>449 €</a:t>
-            </a:r>
-            <a:r>
-              <a:rPr sz="1200" b="0">
-                <a:solidFill>
-                  <a:srgbClr val="7F8B9B"/>
-                </a:solidFill>
-                <a:latin typeface="DM Sans"/>
-              </a:rPr>
-              <a:t>  / mois</a:t>
-            </a:r>
-          </a:p>
-        </p:txBody>
-      </p:sp>
-      <p:sp>
-        <p:nvSpPr>
-          <p:cNvPr id="24" name="TextBox 23"/>
-          <p:cNvSpPr txBox="1"/>
-          <p:nvPr/>
-        </p:nvSpPr>
-        <p:spPr>
-          <a:xfrm>
-            <a:off x="6461606" y="3383280"/>
-            <a:ext cx="2087803" cy="640080"/>
-          </a:xfrm>
-          <a:prstGeom prst="rect">
-            <a:avLst/>
-          </a:prstGeom>
-          <a:noFill/>
-        </p:spPr>
-        <p:txBody>
-          <a:bodyPr wrap="square" anchor="t" lIns="0" rIns="0" tIns="0" bIns="0">
-            <a:spAutoFit/>
-          </a:bodyPr>
-          <a:lstStyle/>
-          <a:p>
-            <a:pPr algn="l">
-              <a:lnSpc>
-                <a:spcPct val="115000"/>
-              </a:lnSpc>
-            </a:pPr>
-            <a:r>
-              <a:rPr sz="1150" b="0">
-                <a:solidFill>
-                  <a:srgbClr val="A9B4C2"/>
-                </a:solidFill>
-                <a:latin typeface="DM Sans"/>
-              </a:rPr>
-              <a:t>1 à 10 M$ · + oracle Web, traçage, sosies, clé d'identité, Cosignataire en option</a:t>
-            </a:r>
-          </a:p>
-        </p:txBody>
-      </p:sp>
-      <p:sp>
-        <p:nvSpPr>
-          <p:cNvPr id="25" name="Rounded Rectangle 24"/>
+              <a:t>mise en attente : rien ne part, même avec toutes les signatures · oracle Web, traçage, sosies · clé d'identité, clé de contrainte, gel · rapport d'incident</a:t>
+            </a:r>
+          </a:p>
+        </p:txBody>
+      </p:sp>
+      <p:sp>
+        <p:nvSpPr>
+          <p:cNvPr id="31" name="Rounded Rectangle 30"/>
           <p:cNvSpPr/>
           <p:nvPr/>
         </p:nvSpPr>
         <p:spPr>
           <a:xfrm>
-            <a:off x="8915169" y="2194560"/>
-            <a:ext cx="2545003" cy="1965960"/>
+            <a:off x="8915169" y="2103120"/>
+            <a:ext cx="2545003" cy="2514600"/>
           </a:xfrm>
           <a:prstGeom prst="roundRect">
             <a:avLst>
-              <a:gd name="adj" fmla="val 8000"/>
+              <a:gd name="adj" fmla="val 6000"/>
             </a:avLst>
           </a:prstGeom>
           <a:solidFill>
@@ -17053,13 +17323,144 @@
       </p:sp>
       <p:sp>
         <p:nvSpPr>
-          <p:cNvPr id="26" name="TextBox 25"/>
-          <p:cNvSpPr txBox="1"/>
-          <p:nvPr/>
-        </p:nvSpPr>
-        <p:spPr>
-          <a:xfrm>
-            <a:off x="9189489" y="2395728"/>
+          <p:cNvPr id="32" name="Rectangle 31"/>
+          <p:cNvSpPr/>
+          <p:nvPr/>
+        </p:nvSpPr>
+        <p:spPr>
+          <a:xfrm>
+            <a:off x="8915169" y="2103120"/>
+            <a:ext cx="54864" cy="2514600"/>
+          </a:xfrm>
+          <a:prstGeom prst="rect">
+            <a:avLst/>
+          </a:prstGeom>
+          <a:solidFill>
+            <a:srgbClr val="C7FA70"/>
+          </a:solidFill>
+          <a:ln>
+            <a:noFill/>
+          </a:ln>
+          <a:effectLst/>
+        </p:spPr>
+        <p:style>
+          <a:lnRef idx="1">
+            <a:schemeClr val="accent1"/>
+          </a:lnRef>
+          <a:fillRef idx="3">
+            <a:schemeClr val="accent1"/>
+          </a:fillRef>
+          <a:effectRef idx="2">
+            <a:schemeClr val="accent1"/>
+          </a:effectRef>
+          <a:fontRef idx="minor">
+            <a:schemeClr val="lt1"/>
+          </a:fontRef>
+        </p:style>
+        <p:txBody>
+          <a:bodyPr rtlCol="0" anchor="ctr"/>
+          <a:lstStyle/>
+          <a:p>
+            <a:pPr algn="ctr"/>
+          </a:p>
+        </p:txBody>
+      </p:sp>
+      <p:sp>
+        <p:nvSpPr>
+          <p:cNvPr id="33" name="TextBox 32"/>
+          <p:cNvSpPr txBox="1"/>
+          <p:nvPr/>
+        </p:nvSpPr>
+        <p:spPr>
+          <a:xfrm>
+            <a:off x="9189489" y="2286000"/>
+            <a:ext cx="2087803" cy="320040"/>
+          </a:xfrm>
+          <a:prstGeom prst="rect">
+            <a:avLst/>
+          </a:prstGeom>
+          <a:noFill/>
+        </p:spPr>
+        <p:txBody>
+          <a:bodyPr wrap="square" anchor="t" lIns="0" rIns="0" tIns="0" bIns="0">
+            <a:spAutoFit/>
+          </a:bodyPr>
+          <a:lstStyle/>
+          <a:p>
+            <a:pPr algn="l">
+              <a:lnSpc>
+                <a:spcPct val="115000"/>
+              </a:lnSpc>
+            </a:pPr>
+            <a:r>
+              <a:rPr sz="1250" b="1">
+                <a:solidFill>
+                  <a:srgbClr val="A9B4C2"/>
+                </a:solidFill>
+                <a:latin typeface="DM Sans"/>
+              </a:rPr>
+              <a:t>Premium</a:t>
+            </a:r>
+          </a:p>
+        </p:txBody>
+      </p:sp>
+      <p:sp>
+        <p:nvSpPr>
+          <p:cNvPr id="34" name="TextBox 33"/>
+          <p:cNvSpPr txBox="1"/>
+          <p:nvPr/>
+        </p:nvSpPr>
+        <p:spPr>
+          <a:xfrm>
+            <a:off x="9189489" y="2560320"/>
+            <a:ext cx="2087803" cy="548640"/>
+          </a:xfrm>
+          <a:prstGeom prst="rect">
+            <a:avLst/>
+          </a:prstGeom>
+          <a:noFill/>
+        </p:spPr>
+        <p:txBody>
+          <a:bodyPr wrap="square" anchor="t" lIns="0" rIns="0" tIns="0" bIns="0">
+            <a:spAutoFit/>
+          </a:bodyPr>
+          <a:lstStyle/>
+          <a:p>
+            <a:pPr algn="l">
+              <a:lnSpc>
+                <a:spcPct val="115000"/>
+              </a:lnSpc>
+            </a:pPr>
+            <a:r>
+              <a:rPr sz="3000" b="1">
+                <a:solidFill>
+                  <a:srgbClr val="F6F9FC"/>
+                </a:solidFill>
+                <a:latin typeface="Manrope"/>
+              </a:rPr>
+              <a:t>990 €</a:t>
+            </a:r>
+            <a:r>
+              <a:rPr sz="1100" b="0">
+                <a:solidFill>
+                  <a:srgbClr val="7F8B9B"/>
+                </a:solidFill>
+                <a:latin typeface="DM Sans"/>
+              </a:rPr>
+              <a:t>  / mois</a:t>
+            </a:r>
+          </a:p>
+        </p:txBody>
+      </p:sp>
+      <p:sp>
+        <p:nvSpPr>
+          <p:cNvPr id="35" name="TextBox 34"/>
+          <p:cNvSpPr txBox="1"/>
+          <p:nvPr/>
+        </p:nvSpPr>
+        <p:spPr>
+          <a:xfrm>
+            <a:off x="9189489" y="3154680"/>
             <a:ext cx="2087803" cy="365760"/>
           </a:xfrm>
           <a:prstGeom prst="rect">
@@ -17079,27 +17480,66 @@
               </a:lnSpc>
             </a:pPr>
             <a:r>
-              <a:rPr sz="1300" b="1">
+              <a:rPr sz="1500" b="1">
+                <a:solidFill>
+                  <a:srgbClr val="C7FA70"/>
+                </a:solidFill>
+                <a:latin typeface="Manrope"/>
+              </a:rPr>
+              <a:t>+ un refus</a:t>
+            </a:r>
+          </a:p>
+        </p:txBody>
+      </p:sp>
+      <p:sp>
+        <p:nvSpPr>
+          <p:cNvPr id="36" name="TextBox 35"/>
+          <p:cNvSpPr txBox="1"/>
+          <p:nvPr/>
+        </p:nvSpPr>
+        <p:spPr>
+          <a:xfrm>
+            <a:off x="9189489" y="3520440"/>
+            <a:ext cx="2087803" cy="1005840"/>
+          </a:xfrm>
+          <a:prstGeom prst="rect">
+            <a:avLst/>
+          </a:prstGeom>
+          <a:noFill/>
+        </p:spPr>
+        <p:txBody>
+          <a:bodyPr wrap="square" anchor="t" lIns="0" rIns="0" tIns="0" bIns="0">
+            <a:spAutoFit/>
+          </a:bodyPr>
+          <a:lstStyle/>
+          <a:p>
+            <a:pPr algn="l">
+              <a:lnSpc>
+                <a:spcPct val="112000"/>
+              </a:lnSpc>
+            </a:pPr>
+            <a:r>
+              <a:rPr sz="1050" b="0">
                 <a:solidFill>
                   <a:srgbClr val="A9B4C2"/>
                 </a:solidFill>
                 <a:latin typeface="DM Sans"/>
               </a:rPr>
-              <a:t>Premium</a:t>
-            </a:r>
-          </a:p>
-        </p:txBody>
-      </p:sp>
-      <p:sp>
-        <p:nvSpPr>
-          <p:cNvPr id="27" name="TextBox 26"/>
-          <p:cNvSpPr txBox="1"/>
-          <p:nvPr/>
-        </p:nvSpPr>
-        <p:spPr>
-          <a:xfrm>
-            <a:off x="9189489" y="2743200"/>
-            <a:ext cx="2087803" cy="640080"/>
+              <a:t>mode Cosignataire : un agent occupe un siège de signataire et peut dire non, dérogation humaine après délai · réglages sur mesure · support, disponibilité garantie</a:t>
+            </a:r>
+          </a:p>
+        </p:txBody>
+      </p:sp>
+      <p:sp>
+        <p:nvSpPr>
+          <p:cNvPr id="37" name="TextBox 36"/>
+          <p:cNvSpPr txBox="1"/>
+          <p:nvPr/>
+        </p:nvSpPr>
+        <p:spPr>
+          <a:xfrm>
+            <a:off x="731520" y="4864608"/>
+            <a:ext cx="1325880" cy="310896"/>
           </a:xfrm>
           <a:prstGeom prst="rect">
             <a:avLst/>
@@ -17114,40 +17554,31 @@
           <a:p>
             <a:pPr algn="l">
               <a:lnSpc>
-                <a:spcPct val="115000"/>
-              </a:lnSpc>
-            </a:pPr>
-            <a:r>
-              <a:rPr sz="3400" b="1">
-                <a:solidFill>
-                  <a:srgbClr val="F6F9FC"/>
-                </a:solidFill>
-                <a:latin typeface="Manrope"/>
-              </a:rPr>
-              <a:t>990 €</a:t>
-            </a:r>
-            <a:r>
-              <a:rPr sz="1200" b="0">
+                <a:spcPct val="105000"/>
+              </a:lnSpc>
+            </a:pPr>
+            <a:r>
+              <a:rPr sz="1000" b="0">
                 <a:solidFill>
                   <a:srgbClr val="7F8B9B"/>
                 </a:solidFill>
                 <a:latin typeface="DM Sans"/>
               </a:rPr>
-              <a:t>  / mois</a:t>
-            </a:r>
-          </a:p>
-        </p:txBody>
-      </p:sp>
-      <p:sp>
-        <p:nvSpPr>
-          <p:cNvPr id="28" name="TextBox 27"/>
-          <p:cNvSpPr txBox="1"/>
-          <p:nvPr/>
-        </p:nvSpPr>
-        <p:spPr>
-          <a:xfrm>
-            <a:off x="9189489" y="3383280"/>
-            <a:ext cx="2087803" cy="640080"/>
+              <a:t>Pourquoi ces prix</a:t>
+            </a:r>
+          </a:p>
+        </p:txBody>
+      </p:sp>
+      <p:sp>
+        <p:nvSpPr>
+          <p:cNvPr id="38" name="TextBox 37"/>
+          <p:cNvSpPr txBox="1"/>
+          <p:nvPr/>
+        </p:nvSpPr>
+        <p:spPr>
+          <a:xfrm>
+            <a:off x="2194560" y="4864608"/>
+            <a:ext cx="9128455" cy="310896"/>
           </a:xfrm>
           <a:prstGeom prst="rect">
             <a:avLst/>
@@ -17162,94 +17593,16 @@
           <a:p>
             <a:pPr algn="l">
               <a:lnSpc>
-                <a:spcPct val="115000"/>
-              </a:lnSpc>
-            </a:pPr>
-            <a:r>
-              <a:rPr sz="1150" b="0">
-                <a:solidFill>
-                  <a:srgbClr val="A9B4C2"/>
+                <a:spcPct val="105000"/>
+              </a:lnSpc>
+            </a:pPr>
+            <a:r>
+              <a:rPr sz="1000" b="0">
+                <a:solidFill>
+                  <a:srgbClr val="7F8B9B"/>
                 </a:solidFill>
                 <a:latin typeface="DM Sans"/>
               </a:rPr>
-              <a:t>&gt; 10 M$ ou &gt; 5 multisigs · sur mesure, support prioritaire, disponibilité garantie · Entreprise sur devis</a:t>
-            </a:r>
-          </a:p>
-        </p:txBody>
-      </p:sp>
-      <p:sp>
-        <p:nvSpPr>
-          <p:cNvPr id="29" name="TextBox 28"/>
-          <p:cNvSpPr txBox="1"/>
-          <p:nvPr/>
-        </p:nvSpPr>
-        <p:spPr>
-          <a:xfrm>
-            <a:off x="731520" y="4453128"/>
-            <a:ext cx="2788920" cy="329184"/>
-          </a:xfrm>
-          <a:prstGeom prst="rect">
-            <a:avLst/>
-          </a:prstGeom>
-          <a:noFill/>
-        </p:spPr>
-        <p:txBody>
-          <a:bodyPr wrap="square" anchor="t" lIns="0" rIns="0" tIns="0" bIns="0">
-            <a:spAutoFit/>
-          </a:bodyPr>
-          <a:lstStyle/>
-          <a:p>
-            <a:pPr algn="l">
-              <a:lnSpc>
-                <a:spcPct val="105000"/>
-              </a:lnSpc>
-            </a:pPr>
-            <a:r>
-              <a:rPr sz="1000" b="0">
-                <a:solidFill>
-                  <a:srgbClr val="7F8B9B"/>
-                </a:solidFill>
-                <a:latin typeface="DM Sans"/>
-              </a:rPr>
-              <a:t>Pourquoi 449 €</a:t>
-            </a:r>
-          </a:p>
-        </p:txBody>
-      </p:sp>
-      <p:sp>
-        <p:nvSpPr>
-          <p:cNvPr id="30" name="TextBox 29"/>
-          <p:cNvSpPr txBox="1"/>
-          <p:nvPr/>
-        </p:nvSpPr>
-        <p:spPr>
-          <a:xfrm>
-            <a:off x="3657600" y="4453128"/>
-            <a:ext cx="7665415" cy="329184"/>
-          </a:xfrm>
-          <a:prstGeom prst="rect">
-            <a:avLst/>
-          </a:prstGeom>
-          <a:noFill/>
-        </p:spPr>
-        <p:txBody>
-          <a:bodyPr wrap="square" anchor="t" lIns="0" rIns="0" tIns="0" bIns="0">
-            <a:spAutoFit/>
-          </a:bodyPr>
-          <a:lstStyle/>
-          <a:p>
-            <a:pPr algn="l">
-              <a:lnSpc>
-                <a:spcPct val="105000"/>
-              </a:lnSpc>
-            </a:pPr>
-            <a:r>
-              <a:rPr sz="1000" b="0">
-                <a:solidFill>
-                  <a:srgbClr val="7F8B9B"/>
-                </a:solidFill>
-                <a:latin typeface="DM Sans"/>
-              </a:rPr>
               <a:t/>
             </a:r>
           </a:p>
@@ -17257,13 +17610,13 @@
       </p:sp>
       <p:sp>
         <p:nvSpPr>
-          <p:cNvPr id="31" name="Rectangle 30"/>
+          <p:cNvPr id="39" name="Rectangle 38"/>
           <p:cNvSpPr/>
           <p:nvPr/>
         </p:nvSpPr>
         <p:spPr>
           <a:xfrm>
-            <a:off x="731520" y="4712304"/>
+            <a:off x="731520" y="5105496"/>
             <a:ext cx="10728655" cy="6000"/>
           </a:xfrm>
           <a:prstGeom prst="rect">
@@ -17301,14 +17654,14 @@
       </p:sp>
       <p:sp>
         <p:nvSpPr>
-          <p:cNvPr id="32" name="TextBox 31"/>
-          <p:cNvSpPr txBox="1"/>
-          <p:nvPr/>
-        </p:nvSpPr>
-        <p:spPr>
-          <a:xfrm>
-            <a:off x="731520" y="4782312"/>
-            <a:ext cx="2788920" cy="329184"/>
+          <p:cNvPr id="40" name="TextBox 39"/>
+          <p:cNvSpPr txBox="1"/>
+          <p:nvPr/>
+        </p:nvSpPr>
+        <p:spPr>
+          <a:xfrm>
+            <a:off x="731520" y="5175504"/>
+            <a:ext cx="1325880" cy="310896"/>
           </a:xfrm>
           <a:prstGeom prst="rect">
             <a:avLst/>
@@ -17327,27 +17680,27 @@
               </a:lnSpc>
             </a:pPr>
             <a:r>
-              <a:rPr sz="1150" b="1">
+              <a:rPr sz="1100" b="1">
                 <a:solidFill>
                   <a:srgbClr val="F6F9FC"/>
                 </a:solidFill>
                 <a:latin typeface="DM Sans"/>
               </a:rPr>
-              <a:t>Perte annuelle évitée</a:t>
-            </a:r>
-          </a:p>
-        </p:txBody>
-      </p:sp>
-      <p:sp>
-        <p:nvSpPr>
-          <p:cNvPr id="33" name="TextBox 32"/>
-          <p:cNvSpPr txBox="1"/>
-          <p:nvPr/>
-        </p:nvSpPr>
-        <p:spPr>
-          <a:xfrm>
-            <a:off x="3657600" y="4782312"/>
-            <a:ext cx="7665415" cy="329184"/>
+              <a:t>449 €</a:t>
+            </a:r>
+          </a:p>
+        </p:txBody>
+      </p:sp>
+      <p:sp>
+        <p:nvSpPr>
+          <p:cNvPr id="41" name="TextBox 40"/>
+          <p:cNvSpPr txBox="1"/>
+          <p:nvPr/>
+        </p:nvSpPr>
+        <p:spPr>
+          <a:xfrm>
+            <a:off x="2194560" y="5175504"/>
+            <a:ext cx="9128455" cy="310896"/>
           </a:xfrm>
           <a:prstGeom prst="rect">
             <a:avLst/>
@@ -17366,26 +17719,26 @@
               </a:lnSpc>
             </a:pPr>
             <a:r>
-              <a:rPr sz="1150" b="0">
+              <a:rPr sz="1100" b="0">
                 <a:solidFill>
                   <a:srgbClr val="E7EDF4"/>
                 </a:solidFill>
                 <a:latin typeface="DM Sans"/>
               </a:rPr>
-              <a:t>9,5 % d'incidents (TRM ÷ population) × 1,3 M$ médiane × 91 % d'efficacité ≈ 112 k$/an  (22 k$ à périmètre restreint)</a:t>
-            </a:r>
-          </a:p>
-        </p:txBody>
-      </p:sp>
-      <p:sp>
-        <p:nvSpPr>
-          <p:cNvPr id="34" name="Rectangle 33"/>
+              <a:t>5 % de la perte annuelle évitée (9,5 % d'incidents × 1,3 M$ médiane × 91 % ≈ 112 k$/an) · repère : Safe Pro Business, 669 €/mois</a:t>
+            </a:r>
+          </a:p>
+        </p:txBody>
+      </p:sp>
+      <p:sp>
+        <p:nvSpPr>
+          <p:cNvPr id="42" name="Rectangle 41"/>
           <p:cNvSpPr/>
           <p:nvPr/>
         </p:nvSpPr>
         <p:spPr>
           <a:xfrm>
-            <a:off x="731520" y="5041488"/>
+            <a:off x="731520" y="5416392"/>
             <a:ext cx="10728655" cy="6000"/>
           </a:xfrm>
           <a:prstGeom prst="rect">
@@ -17423,14 +17776,14 @@
       </p:sp>
       <p:sp>
         <p:nvSpPr>
-          <p:cNvPr id="35" name="TextBox 34"/>
-          <p:cNvSpPr txBox="1"/>
-          <p:nvPr/>
-        </p:nvSpPr>
-        <p:spPr>
-          <a:xfrm>
-            <a:off x="731520" y="5111496"/>
-            <a:ext cx="2788920" cy="329184"/>
+          <p:cNvPr id="43" name="TextBox 42"/>
+          <p:cNvSpPr txBox="1"/>
+          <p:nvPr/>
+        </p:nvSpPr>
+        <p:spPr>
+          <a:xfrm>
+            <a:off x="731520" y="5486400"/>
+            <a:ext cx="1325880" cy="310896"/>
           </a:xfrm>
           <a:prstGeom prst="rect">
             <a:avLst/>
@@ -17449,27 +17802,27 @@
               </a:lnSpc>
             </a:pPr>
             <a:r>
-              <a:rPr sz="1150" b="1">
+              <a:rPr sz="1100" b="1">
                 <a:solidFill>
                   <a:srgbClr val="F6F9FC"/>
                 </a:solidFill>
                 <a:latin typeface="DM Sans"/>
               </a:rPr>
-              <a:t>Prix / valeur</a:t>
-            </a:r>
-          </a:p>
-        </p:txBody>
-      </p:sp>
-      <p:sp>
-        <p:nvSpPr>
-          <p:cNvPr id="36" name="TextBox 35"/>
-          <p:cNvSpPr txBox="1"/>
-          <p:nvPr/>
-        </p:nvSpPr>
-        <p:spPr>
-          <a:xfrm>
-            <a:off x="3657600" y="5111496"/>
-            <a:ext cx="7665415" cy="329184"/>
+              <a:t>990 €</a:t>
+            </a:r>
+          </a:p>
+        </p:txBody>
+      </p:sp>
+      <p:sp>
+        <p:nvSpPr>
+          <p:cNvPr id="44" name="TextBox 43"/>
+          <p:cNvSpPr txBox="1"/>
+          <p:nvPr/>
+        </p:nvSpPr>
+        <p:spPr>
+          <a:xfrm>
+            <a:off x="2194560" y="5486400"/>
+            <a:ext cx="9128455" cy="310896"/>
           </a:xfrm>
           <a:prstGeom prst="rect">
             <a:avLst/>
@@ -17488,26 +17841,26 @@
               </a:lnSpc>
             </a:pPr>
             <a:r>
-              <a:rPr sz="1150" b="0">
+              <a:rPr sz="1100" b="0">
                 <a:solidFill>
                   <a:srgbClr val="E7EDF4"/>
                 </a:solidFill>
                 <a:latin typeface="DM Sans"/>
               </a:rPr>
-              <a:t>5 400 €/an = 5 % de la perte évitée (règle : ≤ 10 %)</a:t>
-            </a:r>
-          </a:p>
-        </p:txBody>
-      </p:sp>
-      <p:sp>
-        <p:nvSpPr>
-          <p:cNvPr id="37" name="Rectangle 36"/>
+              <a:t>10 % de la perte évitée, le plafond : le seul niveau où quelqu'un dit non à votre place quand tous vos signataires sont trompés · repère : Fireblocks, 999 $/mois</a:t>
+            </a:r>
+          </a:p>
+        </p:txBody>
+      </p:sp>
+      <p:sp>
+        <p:nvSpPr>
+          <p:cNvPr id="45" name="Rectangle 44"/>
           <p:cNvSpPr/>
           <p:nvPr/>
         </p:nvSpPr>
         <p:spPr>
           <a:xfrm>
-            <a:off x="731520" y="5370672"/>
+            <a:off x="731520" y="5727288"/>
             <a:ext cx="10728655" cy="6000"/>
           </a:xfrm>
           <a:prstGeom prst="rect">
@@ -17545,14 +17898,14 @@
       </p:sp>
       <p:sp>
         <p:nvSpPr>
-          <p:cNvPr id="38" name="TextBox 37"/>
-          <p:cNvSpPr txBox="1"/>
-          <p:nvPr/>
-        </p:nvSpPr>
-        <p:spPr>
-          <a:xfrm>
-            <a:off x="731520" y="5440680"/>
-            <a:ext cx="2788920" cy="329184"/>
+          <p:cNvPr id="46" name="TextBox 45"/>
+          <p:cNvSpPr txBox="1"/>
+          <p:nvPr/>
+        </p:nvSpPr>
+        <p:spPr>
+          <a:xfrm>
+            <a:off x="731520" y="5797296"/>
+            <a:ext cx="1325880" cy="310896"/>
           </a:xfrm>
           <a:prstGeom prst="rect">
             <a:avLst/>
@@ -17571,27 +17924,27 @@
               </a:lnSpc>
             </a:pPr>
             <a:r>
-              <a:rPr sz="1150" b="1">
+              <a:rPr sz="1100" b="1">
                 <a:solidFill>
                   <a:srgbClr val="F6F9FC"/>
                 </a:solidFill>
                 <a:latin typeface="DM Sans"/>
               </a:rPr>
-              <a:t>Repère du client · coût marginal</a:t>
-            </a:r>
-          </a:p>
-        </p:txBody>
-      </p:sp>
-      <p:sp>
-        <p:nvSpPr>
-          <p:cNvPr id="39" name="TextBox 38"/>
-          <p:cNvSpPr txBox="1"/>
-          <p:nvPr/>
-        </p:nvSpPr>
-        <p:spPr>
-          <a:xfrm>
-            <a:off x="3657600" y="5440680"/>
-            <a:ext cx="7665415" cy="329184"/>
+              <a:t>Entreprise</a:t>
+            </a:r>
+          </a:p>
+        </p:txBody>
+      </p:sp>
+      <p:sp>
+        <p:nvSpPr>
+          <p:cNvPr id="47" name="TextBox 46"/>
+          <p:cNvSpPr txBox="1"/>
+          <p:nvPr/>
+        </p:nvSpPr>
+        <p:spPr>
+          <a:xfrm>
+            <a:off x="2194560" y="5797296"/>
+            <a:ext cx="9128455" cy="310896"/>
           </a:xfrm>
           <a:prstGeom prst="rect">
             <a:avLst/>
@@ -17610,26 +17963,26 @@
               </a:lnSpc>
             </a:pPr>
             <a:r>
-              <a:rPr sz="1150" b="0">
+              <a:rPr sz="1100" b="0">
                 <a:solidFill>
                   <a:srgbClr val="E7EDF4"/>
                 </a:solidFill>
                 <a:latin typeface="DM Sans"/>
               </a:rPr>
-              <a:t>Safe Pro Business 669 €/mois (règles à écrire) · Fireblocks 999 $/mois (dépositaire) · coût marginal ≈ 1,2 $/client/mois</a:t>
-            </a:r>
-          </a:p>
-        </p:txBody>
-      </p:sp>
-      <p:sp>
-        <p:nvSpPr>
-          <p:cNvPr id="40" name="Rectangle 39"/>
+              <a:t>sur devis : plusieurs entités, audit, intégrations · coût marginal ≈ 1,2 $/client/mois : la valeur dicte le prix</a:t>
+            </a:r>
+          </a:p>
+        </p:txBody>
+      </p:sp>
+      <p:sp>
+        <p:nvSpPr>
+          <p:cNvPr id="48" name="Rectangle 47"/>
           <p:cNvSpPr/>
           <p:nvPr/>
         </p:nvSpPr>
         <p:spPr>
           <a:xfrm>
-            <a:off x="731520" y="5699856"/>
+            <a:off x="731520" y="6038184"/>
             <a:ext cx="10728655" cy="6000"/>
           </a:xfrm>
           <a:prstGeom prst="rect">

</xml_diff>

<commit_message>
[auto] Mise à jour 11/10 10:12
</commit_message>
<xml_diff>
--- a/shared/pitch/Breaker-pitch.pptx
+++ b/shared/pitch/Breaker-pitch.pptx
@@ -620,7 +620,7 @@
           </a:p>
           <a:p>
             <a:r>
-              <a:t>Ce qui diffère vraiment : la signature en plus ajoute une PERSONNE ; la mise en attente ajoute du TEMPS. Une personne de plus ne sert à rien si les attaquants tiennent déjà assez de clés (Bybit) : là, seul le délai protège, parce qu'il laisse le temps de vérifier, d'annuler, de révoquer sa clé avec la clé d'identité, et parce que l'oracle et le traçage tournent pendant ce temps.</a:t>
+              <a:t>Ce qui diffère vraiment : la signature en plus ajoute une PERSONNE ; la mise en attente ajoute du TEMPS. Une personne de plus ne sert à rien si les attaquants tiennent déjà assez de clés (Bybit) : là, seul le délai protège, parce qu'il laisse le temps de vérifier, d'annuler, de révoquer sa clé avec la clé d'identité froide, et parce que l'oracle et le traçage tournent pendant ce temps.</a:t>
             </a:r>
           </a:p>
           <a:p>
@@ -1053,7 +1053,7 @@
           </a:p>
           <a:p>
             <a:r>
-              <a:t>Et parce que l'attaque vise la personne, chaque signataire a une clé d'identité, gardée à part, pour révoquer seul sa clé volée ; et une clé de contrainte, qui dit oui à l'écran mais gèle en silence si on le force. »</a:t>
+              <a:t>Et parce que l'attaque vise la personne, chaque signataire a une clé d'identité froide : une seconde clé, gardée hors ligne, pour révoquer seul sa clé volée, sans quorum, même coffre gelé ; et une clé de contrainte, qui dit oui à l'écran mais gèle en silence si on le force. Démontré sur Fuji : clé volée, 80 000 approuvés 2 sur 2 par le voleur, révoquée par la victime en une transaction, zéro sorti. »</a:t>
             </a:r>
           </a:p>
           <a:p/>
@@ -13051,8 +13051,8 @@
         </p:nvSpPr>
         <p:spPr>
           <a:xfrm>
-            <a:off x="731520" y="2286000"/>
-            <a:ext cx="2208961" cy="1554480"/>
+            <a:off x="731520" y="2240280"/>
+            <a:ext cx="2208961" cy="1417320"/>
           </a:xfrm>
           <a:prstGeom prst="roundRect">
             <a:avLst>
@@ -13099,7 +13099,7 @@
         </p:nvSpPr>
         <p:spPr>
           <a:xfrm>
-            <a:off x="960120" y="2468880"/>
+            <a:off x="960120" y="2423160"/>
             <a:ext cx="1843201" cy="457200"/>
           </a:xfrm>
           <a:prstGeom prst="rect">
@@ -13138,8 +13138,8 @@
         </p:nvSpPr>
         <p:spPr>
           <a:xfrm>
-            <a:off x="960120" y="2907792"/>
-            <a:ext cx="1843201" cy="822960"/>
+            <a:off x="960120" y="2862072"/>
+            <a:ext cx="1843201" cy="685800"/>
           </a:xfrm>
           <a:prstGeom prst="rect">
             <a:avLst/>
@@ -13177,7 +13177,7 @@
         </p:nvSpPr>
         <p:spPr>
           <a:xfrm>
-            <a:off x="3050209" y="2834640"/>
+            <a:off x="3050209" y="2720340"/>
             <a:ext cx="411480" cy="457200"/>
           </a:xfrm>
           <a:prstGeom prst="rect">
@@ -13216,8 +13216,8 @@
         </p:nvSpPr>
         <p:spPr>
           <a:xfrm>
-            <a:off x="3571417" y="2286000"/>
-            <a:ext cx="2208961" cy="1554480"/>
+            <a:off x="3571417" y="2240280"/>
+            <a:ext cx="2208961" cy="1417320"/>
           </a:xfrm>
           <a:prstGeom prst="roundRect">
             <a:avLst>
@@ -13264,8 +13264,8 @@
         </p:nvSpPr>
         <p:spPr>
           <a:xfrm>
-            <a:off x="3571417" y="2286000"/>
-            <a:ext cx="54864" cy="1554480"/>
+            <a:off x="3571417" y="2240280"/>
+            <a:ext cx="54864" cy="1417320"/>
           </a:xfrm>
           <a:prstGeom prst="rect">
             <a:avLst/>
@@ -13308,7 +13308,7 @@
         </p:nvSpPr>
         <p:spPr>
           <a:xfrm>
-            <a:off x="3800017" y="2468880"/>
+            <a:off x="3800017" y="2423160"/>
             <a:ext cx="1843201" cy="457200"/>
           </a:xfrm>
           <a:prstGeom prst="rect">
@@ -13347,8 +13347,8 @@
         </p:nvSpPr>
         <p:spPr>
           <a:xfrm>
-            <a:off x="3800017" y="2907792"/>
-            <a:ext cx="1843201" cy="822960"/>
+            <a:off x="3800017" y="2862072"/>
+            <a:ext cx="1843201" cy="685800"/>
           </a:xfrm>
           <a:prstGeom prst="rect">
             <a:avLst/>
@@ -13386,7 +13386,7 @@
         </p:nvSpPr>
         <p:spPr>
           <a:xfrm>
-            <a:off x="5890106" y="2834640"/>
+            <a:off x="5890106" y="2720340"/>
             <a:ext cx="411480" cy="457200"/>
           </a:xfrm>
           <a:prstGeom prst="rect">
@@ -13425,8 +13425,8 @@
         </p:nvSpPr>
         <p:spPr>
           <a:xfrm>
-            <a:off x="6411314" y="2286000"/>
-            <a:ext cx="2208961" cy="1554480"/>
+            <a:off x="6411314" y="2240280"/>
+            <a:ext cx="2208961" cy="1417320"/>
           </a:xfrm>
           <a:prstGeom prst="roundRect">
             <a:avLst>
@@ -13473,8 +13473,8 @@
         </p:nvSpPr>
         <p:spPr>
           <a:xfrm>
-            <a:off x="6411314" y="2286000"/>
-            <a:ext cx="54864" cy="1554480"/>
+            <a:off x="6411314" y="2240280"/>
+            <a:ext cx="54864" cy="1417320"/>
           </a:xfrm>
           <a:prstGeom prst="rect">
             <a:avLst/>
@@ -13517,7 +13517,7 @@
         </p:nvSpPr>
         <p:spPr>
           <a:xfrm>
-            <a:off x="6639914" y="2468880"/>
+            <a:off x="6639914" y="2423160"/>
             <a:ext cx="1843201" cy="457200"/>
           </a:xfrm>
           <a:prstGeom prst="rect">
@@ -13556,8 +13556,8 @@
         </p:nvSpPr>
         <p:spPr>
           <a:xfrm>
-            <a:off x="6639914" y="2907792"/>
-            <a:ext cx="1843201" cy="822960"/>
+            <a:off x="6639914" y="2862072"/>
+            <a:ext cx="1843201" cy="685800"/>
           </a:xfrm>
           <a:prstGeom prst="rect">
             <a:avLst/>
@@ -13595,7 +13595,7 @@
         </p:nvSpPr>
         <p:spPr>
           <a:xfrm>
-            <a:off x="8730003" y="2834640"/>
+            <a:off x="8730003" y="2720340"/>
             <a:ext cx="411480" cy="457200"/>
           </a:xfrm>
           <a:prstGeom prst="rect">
@@ -13634,8 +13634,8 @@
         </p:nvSpPr>
         <p:spPr>
           <a:xfrm>
-            <a:off x="9251211" y="2286000"/>
-            <a:ext cx="2208961" cy="1554480"/>
+            <a:off x="9251211" y="2240280"/>
+            <a:ext cx="2208961" cy="1417320"/>
           </a:xfrm>
           <a:prstGeom prst="roundRect">
             <a:avLst>
@@ -13682,7 +13682,7 @@
         </p:nvSpPr>
         <p:spPr>
           <a:xfrm>
-            <a:off x="9479811" y="2468880"/>
+            <a:off x="9479811" y="2423160"/>
             <a:ext cx="1843201" cy="457200"/>
           </a:xfrm>
           <a:prstGeom prst="rect">
@@ -13721,8 +13721,8 @@
         </p:nvSpPr>
         <p:spPr>
           <a:xfrm>
-            <a:off x="9479811" y="2907792"/>
-            <a:ext cx="1843201" cy="822960"/>
+            <a:off x="9479811" y="2862072"/>
+            <a:ext cx="1843201" cy="685800"/>
           </a:xfrm>
           <a:prstGeom prst="rect">
             <a:avLst/>
@@ -13760,7 +13760,7 @@
         </p:nvSpPr>
         <p:spPr>
           <a:xfrm>
-            <a:off x="731520" y="4023360"/>
+            <a:off x="731520" y="3794760"/>
             <a:ext cx="457200" cy="548640"/>
           </a:xfrm>
           <a:prstGeom prst="rect">
@@ -13799,7 +13799,7 @@
         </p:nvSpPr>
         <p:spPr>
           <a:xfrm>
-            <a:off x="1234440" y="4069080"/>
+            <a:off x="1234440" y="3840480"/>
             <a:ext cx="2905658" cy="365760"/>
           </a:xfrm>
           <a:prstGeom prst="rect">
@@ -13838,8 +13838,8 @@
         </p:nvSpPr>
         <p:spPr>
           <a:xfrm>
-            <a:off x="1234440" y="4434840"/>
-            <a:ext cx="2905658" cy="1005840"/>
+            <a:off x="1234440" y="4206240"/>
+            <a:ext cx="2905658" cy="960120"/>
           </a:xfrm>
           <a:prstGeom prst="rect">
             <a:avLst/>
@@ -13877,7 +13877,7 @@
         </p:nvSpPr>
         <p:spPr>
           <a:xfrm>
-            <a:off x="4368698" y="4023360"/>
+            <a:off x="4368698" y="3794760"/>
             <a:ext cx="457200" cy="548640"/>
           </a:xfrm>
           <a:prstGeom prst="rect">
@@ -13916,7 +13916,7 @@
         </p:nvSpPr>
         <p:spPr>
           <a:xfrm>
-            <a:off x="4871618" y="4069080"/>
+            <a:off x="4871618" y="3840480"/>
             <a:ext cx="2905658" cy="365760"/>
           </a:xfrm>
           <a:prstGeom prst="rect">
@@ -13955,8 +13955,8 @@
         </p:nvSpPr>
         <p:spPr>
           <a:xfrm>
-            <a:off x="4871618" y="4434840"/>
-            <a:ext cx="2905658" cy="1005840"/>
+            <a:off x="4871618" y="4206240"/>
+            <a:ext cx="2905658" cy="960120"/>
           </a:xfrm>
           <a:prstGeom prst="rect">
             <a:avLst/>
@@ -13994,7 +13994,7 @@
         </p:nvSpPr>
         <p:spPr>
           <a:xfrm>
-            <a:off x="8005876" y="4023360"/>
+            <a:off x="8005876" y="3794760"/>
             <a:ext cx="457200" cy="548640"/>
           </a:xfrm>
           <a:prstGeom prst="rect">
@@ -14033,7 +14033,7 @@
         </p:nvSpPr>
         <p:spPr>
           <a:xfrm>
-            <a:off x="8508796" y="4069080"/>
+            <a:off x="8508796" y="3840480"/>
             <a:ext cx="2905658" cy="365760"/>
           </a:xfrm>
           <a:prstGeom prst="rect">
@@ -14072,8 +14072,8 @@
         </p:nvSpPr>
         <p:spPr>
           <a:xfrm>
-            <a:off x="8508796" y="4434840"/>
-            <a:ext cx="2905658" cy="1005840"/>
+            <a:off x="8508796" y="4206240"/>
+            <a:ext cx="2905658" cy="960120"/>
           </a:xfrm>
           <a:prstGeom prst="rect">
             <a:avLst/>
@@ -14105,22 +14105,114 @@
       </p:sp>
       <p:sp>
         <p:nvSpPr>
-          <p:cNvPr id="39" name="TextBox 38"/>
-          <p:cNvSpPr txBox="1"/>
-          <p:nvPr/>
-        </p:nvSpPr>
-        <p:spPr>
-          <a:xfrm>
-            <a:off x="731520" y="5349240"/>
-            <a:ext cx="10728655" cy="365760"/>
-          </a:xfrm>
-          <a:prstGeom prst="rect">
-            <a:avLst/>
-          </a:prstGeom>
-          <a:noFill/>
-        </p:spPr>
-        <p:txBody>
-          <a:bodyPr wrap="square" anchor="t" lIns="0" rIns="0" tIns="0" bIns="0">
+          <p:cNvPr id="39" name="Rounded Rectangle 38"/>
+          <p:cNvSpPr/>
+          <p:nvPr/>
+        </p:nvSpPr>
+        <p:spPr>
+          <a:xfrm>
+            <a:off x="731520" y="5120640"/>
+            <a:ext cx="10728655" cy="530352"/>
+          </a:xfrm>
+          <a:prstGeom prst="roundRect">
+            <a:avLst>
+              <a:gd name="adj" fmla="val 30000"/>
+            </a:avLst>
+          </a:prstGeom>
+          <a:solidFill>
+            <a:srgbClr val="101C2E"/>
+          </a:solidFill>
+          <a:ln w="9525">
+            <a:solidFill>
+              <a:srgbClr val="C7FA70"/>
+            </a:solidFill>
+          </a:ln>
+          <a:effectLst/>
+        </p:spPr>
+        <p:style>
+          <a:lnRef idx="1">
+            <a:schemeClr val="accent1"/>
+          </a:lnRef>
+          <a:fillRef idx="3">
+            <a:schemeClr val="accent1"/>
+          </a:fillRef>
+          <a:effectRef idx="2">
+            <a:schemeClr val="accent1"/>
+          </a:effectRef>
+          <a:fontRef idx="minor">
+            <a:schemeClr val="lt1"/>
+          </a:fontRef>
+        </p:style>
+        <p:txBody>
+          <a:bodyPr rtlCol="0" anchor="ctr"/>
+          <a:lstStyle/>
+          <a:p>
+            <a:pPr algn="ctr"/>
+          </a:p>
+        </p:txBody>
+      </p:sp>
+      <p:sp>
+        <p:nvSpPr>
+          <p:cNvPr id="40" name="Rectangle 39"/>
+          <p:cNvSpPr/>
+          <p:nvPr/>
+        </p:nvSpPr>
+        <p:spPr>
+          <a:xfrm>
+            <a:off x="731520" y="5120640"/>
+            <a:ext cx="54864" cy="530352"/>
+          </a:xfrm>
+          <a:prstGeom prst="rect">
+            <a:avLst/>
+          </a:prstGeom>
+          <a:solidFill>
+            <a:srgbClr val="C7FA70"/>
+          </a:solidFill>
+          <a:ln>
+            <a:noFill/>
+          </a:ln>
+          <a:effectLst/>
+        </p:spPr>
+        <p:style>
+          <a:lnRef idx="1">
+            <a:schemeClr val="accent1"/>
+          </a:lnRef>
+          <a:fillRef idx="3">
+            <a:schemeClr val="accent1"/>
+          </a:fillRef>
+          <a:effectRef idx="2">
+            <a:schemeClr val="accent1"/>
+          </a:effectRef>
+          <a:fontRef idx="minor">
+            <a:schemeClr val="lt1"/>
+          </a:fontRef>
+        </p:style>
+        <p:txBody>
+          <a:bodyPr rtlCol="0" anchor="ctr"/>
+          <a:lstStyle/>
+          <a:p>
+            <a:pPr algn="ctr"/>
+          </a:p>
+        </p:txBody>
+      </p:sp>
+      <p:sp>
+        <p:nvSpPr>
+          <p:cNvPr id="41" name="TextBox 40"/>
+          <p:cNvSpPr txBox="1"/>
+          <p:nvPr/>
+        </p:nvSpPr>
+        <p:spPr>
+          <a:xfrm>
+            <a:off x="1005840" y="5120640"/>
+            <a:ext cx="10271455" cy="530352"/>
+          </a:xfrm>
+          <a:prstGeom prst="rect">
+            <a:avLst/>
+          </a:prstGeom>
+          <a:noFill/>
+        </p:spPr>
+        <p:txBody>
+          <a:bodyPr wrap="square" anchor="ctr" lIns="0" rIns="0" tIns="0" bIns="0">
             <a:spAutoFit/>
           </a:bodyPr>
           <a:lstStyle/>
@@ -14137,29 +14229,47 @@
                 </a:solidFill>
                 <a:latin typeface="DM Sans"/>
               </a:rPr>
-              <a:t>Et protège la personne : </a:t>
-            </a:r>
-            <a:r>
-              <a:rPr sz="1300" b="0">
+              <a:t>Et protège la personne  ·  </a:t>
+            </a:r>
+            <a:r>
+              <a:rPr sz="1500" b="1">
+                <a:solidFill>
+                  <a:srgbClr val="C7FA70"/>
+                </a:solidFill>
+                <a:latin typeface="Manrope"/>
+              </a:rPr>
+              <a:t>Clé d'identité froide</a:t>
+            </a:r>
+            <a:r>
+              <a:rPr sz="1250" b="0">
+                <a:solidFill>
+                  <a:srgbClr val="F6F9FC"/>
+                </a:solidFill>
+                <a:latin typeface="DM Sans"/>
+              </a:rPr>
+              <a:t> : une seconde clé, gardée hors ligne, pour révoquer seul sa clé volée, sans quorum, même coffre gelé.</a:t>
+            </a:r>
+            <a:r>
+              <a:rPr sz="1200" b="0">
                 <a:solidFill>
                   <a:srgbClr val="A9B4C2"/>
                 </a:solidFill>
                 <a:latin typeface="DM Sans"/>
               </a:rPr>
-              <a:t>clé d'identité pour révoquer seul sa clé volée · clé de contrainte qui gèle en silence · probation des clés neuves.</a:t>
-            </a:r>
-          </a:p>
-        </p:txBody>
-      </p:sp>
-      <p:sp>
-        <p:nvSpPr>
-          <p:cNvPr id="40" name="TextBox 39"/>
-          <p:cNvSpPr txBox="1"/>
-          <p:nvPr/>
-        </p:nvSpPr>
-        <p:spPr>
-          <a:xfrm>
-            <a:off x="731520" y="5687568"/>
+              <a:t>  ·  Clé de contrainte : dit « oui » à l'écran, gèle en silence  ·  Probation des clés neuves.</a:t>
+            </a:r>
+          </a:p>
+        </p:txBody>
+      </p:sp>
+      <p:sp>
+        <p:nvSpPr>
+          <p:cNvPr id="42" name="TextBox 41"/>
+          <p:cNvSpPr txBox="1"/>
+          <p:nvPr/>
+        </p:nvSpPr>
+        <p:spPr>
+          <a:xfrm>
+            <a:off x="731520" y="5724144"/>
             <a:ext cx="10728655" cy="457200"/>
           </a:xfrm>
           <a:prstGeom prst="rect">
@@ -17268,7 +17378,7 @@
                 </a:solidFill>
                 <a:latin typeface="DM Sans"/>
               </a:rPr>
-              <a:t>mise en attente : rien ne part, même avec toutes les signatures · oracle Web, traçage, sosies · clé d'identité, clé de contrainte, gel · rapport d'incident</a:t>
+              <a:t>mise en attente : rien ne part, même avec toutes les signatures · oracle Web, traçage, sosies · clé d'identité froide, clé de contrainte, gel · rapport d'incident</a:t>
             </a:r>
           </a:p>
         </p:txBody>

</xml_diff>

<commit_message>
[auto] Mise à jour 11/10 10:26
</commit_message>
<xml_diff>
--- a/shared/pitch/Breaker-pitch.pptx
+++ b/shared/pitch/Breaker-pitch.pptx
@@ -947,7 +947,7 @@
           </a:p>
           <a:p>
             <a:r>
-              <a:t>« Les autres, ce sont les équipes de protocoles, les DAO, les startups et les fonds crypto : une trésorerie de un à dix millions dans un coffre multi-signatures, le plus souvent un Safe, et zéro personne dont c'est le métier. Il y en a au moins 675 à 895 sur les chaînes compatibles Ethereum. Sur Avalanche, où nous sommes nés, entre 32 et 121. Ces chiffres viennent de l'API DeFiLlama lue hier et de DeepDAO ; les calculs sont dans le dépôt. »</a:t>
+              <a:t>« Les autres, ce sont les équipes de protocoles, les DAO, les startups et les fonds crypto : une trésorerie de plus d'un million dans un coffre multi-signatures, le plus souvent un Safe, et zéro personne dont c'est le métier. Il y en a au moins 1 359 à 1 579 sur les chaînes compatibles Ethereum. Sur Avalanche, où nous sommes nés, entre 81 et 121. Ces chiffres viennent de l'API DeFiLlama lue hier et de DeepDAO ; les calculs sont dans le dépôt. »</a:t>
             </a:r>
           </a:p>
           <a:p>
@@ -958,7 +958,7 @@
           <a:p/>
           <a:p>
             <a:r>
-              <a:t>Si question sur la méthode : comptage par seuil de TVL, hypothèse H1 (protocole &gt; 10 M$ ⇒ trésorerie ≥ 1 M$), script reproductible dans shared/business-marche.md § 5.</a:t>
+              <a:t>Si question sur la méthode : comptage par seuil de TVL, hypothèse H1 révisée le 11/10 (protocole &gt; 1 M$ d'actifs ⇒ trésorerie ≥ 1 M$ ; borne prudente &gt; 10 M$ : 675 protocoles, 22 sur Avalanche), script reproductible dans shared/business-marche.md § 5.</a:t>
             </a:r>
           </a:p>
         </p:txBody>
@@ -1379,13 +1379,13 @@
           </a:p>
           <a:p>
             <a:r>
-              <a:t>« Première année : 62 organisations présentées par l'écosystème Avalanche, la moitié en observation, 3 à 6 clients payants selon les taux de conversion du SaaS B2B. L'audit externe avant le premier euro. Puis le même code sur les autres chaînes compatibles. Nos coûts fixes sont de 4 300 euros par mois, deux fondateurs à 2 000 euros : le point mort est à 10 clients Standard, atteignable entre le troisième trimestre 2027 et la mi-2028 selon le taux de conversion, plus tôt avec un seul client Premium. »</a:t>
+              <a:t>« Première année : 111 organisations présentées par l'écosystème Avalanche, la moitié en observation, 5 à 10 clients payants selon les taux de conversion du SaaS B2B. L'audit externe avant le premier euro. Puis le même code sur les autres chaînes compatibles. Nos coûts fixes sont de 4 300 euros par mois, deux fondateurs à 2 000 euros : le point mort est à 10 clients Standard, atteignable entre le deuxième et le troisième trimestre 2027 selon le taux de conversion, plus tôt avec un seul client Premium. »</a:t>
             </a:r>
           </a:p>
           <a:p/>
           <a:p>
             <a:r>
-              <a:t>Si on demande « comment vous arrivez à 10 clients ? » : à l'envers. 10 clients ÷ 8,9 à 18,5 % de conversion = 54 à 112 équipes en observation ÷ une sur deux qui accepte = 108 à 225 équipes à contacter. Avalanche en donne 62 d'ici décembre ; chaque nouvel écosystème EVM en donne autant par semestre : un à trois écosystèmes de plus, donc T3 2027 dans le cas favorable, mi-2028 dans le cas défavorable.</a:t>
+              <a:t>Si on demande « comment vous arrivez à 10 clients ? » : à l'envers. 10 clients ÷ 8,9 à 18,5 % de conversion = 54 à 112 équipes en observation ÷ une sur deux qui accepte = 108 à 225 équipes à contacter. Avalanche en donne 111 d'ici décembre : ça suffit dans le cas favorable (18,5 %), point mort au T2 2027 ; dans le cas défavorable (8,9 %), un écosystème EVM de plus au premier semestre 2027, qui en donne autant, point mort au T3 2027.</a:t>
             </a:r>
           </a:p>
           <a:p/>
@@ -11641,7 +11641,7 @@
                 </a:solidFill>
                 <a:latin typeface="DM Sans"/>
               </a:rPr>
-              <a:t>les organisations qui ont une trésorerie et pas d'équipe sécurité</a:t>
+              <a:t>toute organisation avec plus de 1 M$ de trésorerie et pas d'équipe sécurité</a:t>
             </a:r>
           </a:p>
         </p:txBody>
@@ -11892,13 +11892,13 @@
               </a:lnSpc>
             </a:pPr>
             <a:r>
-              <a:rPr sz="3000" b="1">
+              <a:rPr sz="2400" b="1">
                 <a:solidFill>
                   <a:srgbClr val="F6F9FC"/>
                 </a:solidFill>
                 <a:latin typeface="Manrope"/>
               </a:rPr>
-              <a:t>675</a:t>
+              <a:t>1 359</a:t>
             </a:r>
           </a:p>
         </p:txBody>
@@ -11937,7 +11937,7 @@
                 </a:solidFill>
                 <a:latin typeface="DM Sans"/>
               </a:rPr>
-              <a:t>protocoles &gt; 10 M$ d'actifs gérés, toutes chaînes (API DeFiLlama, 11/10/2026)</a:t>
+              <a:t>protocoles &gt; 1 M$ d'actifs gérés, toutes chaînes, dont 675 &gt; 10 M$ (API DeFiLlama, 11/10/2026)</a:t>
             </a:r>
           </a:p>
         </p:txBody>
@@ -12062,7 +12062,7 @@
               </a:lnSpc>
             </a:pPr>
             <a:r>
-              <a:rPr sz="3000" b="1">
+              <a:rPr sz="2400" b="1">
                 <a:solidFill>
                   <a:srgbClr val="F6F9FC"/>
                 </a:solidFill>
@@ -12232,13 +12232,13 @@
               </a:lnSpc>
             </a:pPr>
             <a:r>
-              <a:rPr sz="3000" b="1">
+              <a:rPr sz="2400" b="1">
                 <a:solidFill>
                   <a:srgbClr val="C7FA70"/>
                 </a:solidFill>
                 <a:latin typeface="Manrope"/>
               </a:rPr>
-              <a:t>32 – 121</a:t>
+              <a:t>81 – 121</a:t>
             </a:r>
           </a:p>
         </p:txBody>
@@ -12277,7 +12277,7 @@
                 </a:solidFill>
                 <a:latin typeface="DM Sans"/>
               </a:rPr>
-              <a:t>organisations adressables sur Avalanche (protocoles &gt; 10 M$, équipes de L1)</a:t>
+              <a:t>organisations adressables sur Avalanche (71 protocoles &gt; 1 M$, 10 à 50 équipes de L1)</a:t>
             </a:r>
           </a:p>
         </p:txBody>
@@ -12402,13 +12402,13 @@
               </a:lnSpc>
             </a:pPr>
             <a:r>
-              <a:rPr sz="3000" b="1">
+              <a:rPr sz="2400" b="1">
                 <a:solidFill>
                   <a:srgbClr val="F6F9FC"/>
                 </a:solidFill>
                 <a:latin typeface="Manrope"/>
               </a:rPr>
-              <a:t>675 – 895</a:t>
+              <a:t>1 359 – 1 579</a:t>
             </a:r>
           </a:p>
         </p:txBody>
@@ -12486,7 +12486,7 @@
                 </a:solidFill>
                 <a:latin typeface="DM Sans"/>
               </a:rPr>
-              <a:t>Protocoles, DAO, startups et fonds crypto : 1 à 10 M$ dans un Safe, zéro personne dont c'est le métier. </a:t>
+              <a:t>Protocoles, DAO, startups et fonds crypto : plus de 1 M$ dans un Safe, zéro personne dont c'est le métier. </a:t>
             </a:r>
             <a:r>
               <a:rPr sz="1600" b="0">
@@ -18666,7 +18666,7 @@
                 </a:solidFill>
                 <a:latin typeface="Manrope"/>
               </a:rPr>
-              <a:t>Première année : 62 organisations présentées, 3 à 6 clients payants.</a:t>
+              <a:t>Première année : 111 organisations présentées, 5 à 10 clients payants.</a:t>
             </a:r>
           </a:p>
         </p:txBody>
@@ -18753,7 +18753,7 @@
                 </a:solidFill>
                 <a:latin typeface="Manrope"/>
               </a:rPr>
-              <a:t>62 contactables</a:t>
+              <a:t>111 contactables</a:t>
             </a:r>
           </a:p>
         </p:txBody>
@@ -18792,7 +18792,7 @@
                 </a:solidFill>
                 <a:latin typeface="DM Sans"/>
               </a:rPr>
-              <a:t>Retro9000 30 + équipes de L1 10 + protocoles &gt; 10 M$ sur Avalanche 22, présentées par l'écosystème</a:t>
+              <a:t>Retro9000 30 + équipes de L1 10 + protocoles &gt; 1 M$ sur Avalanche 71, présentées par l'écosystème</a:t>
             </a:r>
           </a:p>
         </p:txBody>
@@ -18918,7 +18918,7 @@
                 </a:solidFill>
                 <a:latin typeface="Manrope"/>
               </a:rPr>
-              <a:t>31 en observation</a:t>
+              <a:t>56 en observation</a:t>
             </a:r>
           </a:p>
         </p:txBody>
@@ -19127,7 +19127,7 @@
                 </a:solidFill>
                 <a:latin typeface="Manrope"/>
               </a:rPr>
-              <a:t>3 à 6 payants</a:t>
+              <a:t>5 à 10 payants</a:t>
             </a:r>
           </a:p>
         </p:txBody>
@@ -19732,7 +19732,7 @@
                 </a:solidFill>
                 <a:latin typeface="DM Sans"/>
               </a:rPr>
-              <a:t>même code sur une 2e chaîne EVM : marché × 6 à 8</a:t>
+              <a:t>même code sur une 2e chaîne EVM : marché × 11 à 19</a:t>
             </a:r>
           </a:p>
         </p:txBody>
@@ -19815,7 +19815,7 @@
                 </a:solidFill>
                 <a:latin typeface="DM Sans"/>
               </a:rPr>
-              <a:t>T3 2027 – mi-2028</a:t>
+              <a:t>T2 – T3 2027</a:t>
             </a:r>
           </a:p>
         </p:txBody>
@@ -19854,7 +19854,7 @@
                 </a:solidFill>
                 <a:latin typeface="DM Sans"/>
               </a:rPr>
-              <a:t>point mort : 10 clients Standard (coûts fixes 4 300 €/mois : 2 fondateurs à 2 000 € + 300 € d'infra) ; plus tôt avec un Premium</a:t>
+              <a:t>point mort : 10 clients Standard (coûts fixes 4 300 €/mois : 2 fondateurs à 2 000 € + 300 € d'infra) ; Avalanche seul suffit à 18,5 % de conversion, un écosystème EVM de plus à 8,9 % ; plus tôt avec un Premium</a:t>
             </a:r>
           </a:p>
         </p:txBody>

</xml_diff>

<commit_message>
[auto] Mise à jour 11/10 10:47
</commit_message>
<xml_diff>
--- a/shared/pitch/Breaker-pitch.pptx
+++ b/shared/pitch/Breaker-pitch.pptx
@@ -1283,12 +1283,12 @@
           </a:p>
           <a:p>
             <a:r>
-              <a:t>• 9,5 % : TRM Labs compte ≈ 150 incidents significatifs en 2025, rapportés aux 1 579 organisations ≥ 1 M$ (1 359 protocoles &gt; 1 M$ d'actifs, API DeFiLlama, + 220 DAO &gt; 1 M$, DeepDAO). Borne haute : on montre aussi le cas « un incident sur cinq dans notre périmètre » (22 k$).</a:t>
-            </a:r>
-          </a:p>
-          <a:p>
-            <a:r>
-              <a:t>• 1,3 M$ : perte médiane des incidents significatifs de 2025 selon TRM Labs (la moitié coûtent plus, la moitié moins). Immunefi donne 1,5 M$ en DeFi ; CertiK 104 k$ mais sur plus de 700 incidents dont beaucoup de petits. On prend TRM, dont le périmètre ressemble au nôtre.</a:t>
+              <a:t>• 9,5 % : TRM Labs compte ≈ 150 hacks et exploits en 2025 (2,87 Md$), rapportés aux 1 579 organisations ≥ 1 M$ (1 359 protocoles &gt; 1 M$, API DeFiLlama, + 220 DAO &gt; 1 M$, DeepDAO). Borne haute : les 150 incidents couvrent toutes les victimes, plateformes centralisées comprises.</a:t>
+            </a:r>
+          </a:p>
+          <a:p>
+            <a:r>
+              <a:t>• 1,3 M$ : perte médiane des 150 incidents TRM, toutes victimes confondues (moyenne 19,5 M$, tirée par Bybit). Pas une médiane « organisations de 1 à 10 M$ » : cette donnée n'existe pas publiquement. Immunefi donne 1,5 M$ sur les seuls protocoles DeFi, la population la plus proche de la nôtre ; CertiK 104 k$ mais en comptant le phishing d'individus. Pour une organisation de 1 à 10 M$, une fraude de signataires vide le coffre : 1,3 M$ est le bas de la fourchette.</a:t>
             </a:r>
           </a:p>
           <a:p>
@@ -1298,7 +1298,13 @@
           </a:p>
           <a:p>
             <a:r>
-              <a:t>• 9,5 % × 1,3 M$ × 91 % ≈ 112 k$/an.</a:t>
+              <a:t>• 9,5 % × 1,3 M$ × 91 % ≈ 112 k$/an en borne haute. Dans le seul périmètre de Breaker (attaques d'infrastructure TRM : clés, accès, front-ends = 45 incidents sur 150, 76 % de la valeur volée) : 2,9 % × 1,3 M$ × 91 % ≈ 34 k$/an, et Standard représente alors 16 %.</a:t>
+            </a:r>
+          </a:p>
+          <a:p/>
+          <a:p>
+            <a:r>
+              <a:t>SI « SUR QUELLE POPULATION ? » OU « VOS 5 % TIENNENT-ILS ? » : « Les 5 % sont une borne haute, calculée sur toutes les victimes de 2025. La lecture la plus solide pour notre cible est par trésorerie : si l'incident arrive, vous perdez le coffre. Avec 2,9 % d'incidents dans notre périmètre et 91 % retenus, on vous évite 2,6 % de votre trésorerie par an ; Standard coûte 0,05 à 0,5 % de cette trésorerie. La règle des 10 % est respectée dès 2 M$ pour Standard, dès 5 M$ pour Premium, dès 0,7 M$ pour Essentiel : c'est pour ça que les paliers suivent la taille. »</a:t>
             </a:r>
           </a:p>
           <a:p/>
@@ -17648,8 +17654,8 @@
         </p:nvSpPr>
         <p:spPr>
           <a:xfrm>
-            <a:off x="731520" y="4864608"/>
-            <a:ext cx="1325880" cy="310896"/>
+            <a:off x="731520" y="4837176"/>
+            <a:ext cx="1143000" cy="329184"/>
           </a:xfrm>
           <a:prstGeom prst="rect">
             <a:avLst/>
@@ -17687,8 +17693,8 @@
         </p:nvSpPr>
         <p:spPr>
           <a:xfrm>
-            <a:off x="2194560" y="4864608"/>
-            <a:ext cx="9128455" cy="310896"/>
+            <a:off x="2011680" y="4837176"/>
+            <a:ext cx="9311335" cy="329184"/>
           </a:xfrm>
           <a:prstGeom prst="rect">
             <a:avLst/>
@@ -17726,7 +17732,7 @@
         </p:nvSpPr>
         <p:spPr>
           <a:xfrm>
-            <a:off x="731520" y="5105496"/>
+            <a:off x="731520" y="5096352"/>
             <a:ext cx="10728655" cy="6000"/>
           </a:xfrm>
           <a:prstGeom prst="rect">
@@ -17770,8 +17776,8 @@
         </p:nvSpPr>
         <p:spPr>
           <a:xfrm>
-            <a:off x="731520" y="5175504"/>
-            <a:ext cx="1325880" cy="310896"/>
+            <a:off x="731520" y="5166360"/>
+            <a:ext cx="1143000" cy="329184"/>
           </a:xfrm>
           <a:prstGeom prst="rect">
             <a:avLst/>
@@ -17790,7 +17796,7 @@
               </a:lnSpc>
             </a:pPr>
             <a:r>
-              <a:rPr sz="1100" b="1">
+              <a:rPr sz="1050" b="1">
                 <a:solidFill>
                   <a:srgbClr val="F6F9FC"/>
                 </a:solidFill>
@@ -17809,8 +17815,8 @@
         </p:nvSpPr>
         <p:spPr>
           <a:xfrm>
-            <a:off x="2194560" y="5175504"/>
-            <a:ext cx="9128455" cy="310896"/>
+            <a:off x="2011680" y="5166360"/>
+            <a:ext cx="9311335" cy="329184"/>
           </a:xfrm>
           <a:prstGeom prst="rect">
             <a:avLst/>
@@ -17829,13 +17835,13 @@
               </a:lnSpc>
             </a:pPr>
             <a:r>
-              <a:rPr sz="1100" b="0">
+              <a:rPr sz="1050" b="0">
                 <a:solidFill>
                   <a:srgbClr val="E7EDF4"/>
                 </a:solidFill>
                 <a:latin typeface="DM Sans"/>
               </a:rPr>
-              <a:t>5 % de la perte annuelle évitée (9,5 % d'incidents × 1,3 M$ médiane × 91 % ≈ 112 k$/an) · repère : Safe Pro Business, 669 €/mois</a:t>
+              <a:t>5 % de la perte évitée, borne haute (9,5 % × 1,3 M$ × 91 % ≈ 112 k$/an) · 0,05 à 0,5 % de la trésorerie par an · repère : Safe Pro Business 669 €</a:t>
             </a:r>
           </a:p>
         </p:txBody>
@@ -17848,7 +17854,7 @@
         </p:nvSpPr>
         <p:spPr>
           <a:xfrm>
-            <a:off x="731520" y="5416392"/>
+            <a:off x="731520" y="5425536"/>
             <a:ext cx="10728655" cy="6000"/>
           </a:xfrm>
           <a:prstGeom prst="rect">
@@ -17892,8 +17898,8 @@
         </p:nvSpPr>
         <p:spPr>
           <a:xfrm>
-            <a:off x="731520" y="5486400"/>
-            <a:ext cx="1325880" cy="310896"/>
+            <a:off x="731520" y="5495544"/>
+            <a:ext cx="1143000" cy="329184"/>
           </a:xfrm>
           <a:prstGeom prst="rect">
             <a:avLst/>
@@ -17912,7 +17918,7 @@
               </a:lnSpc>
             </a:pPr>
             <a:r>
-              <a:rPr sz="1100" b="1">
+              <a:rPr sz="1050" b="1">
                 <a:solidFill>
                   <a:srgbClr val="F6F9FC"/>
                 </a:solidFill>
@@ -17931,8 +17937,8 @@
         </p:nvSpPr>
         <p:spPr>
           <a:xfrm>
-            <a:off x="2194560" y="5486400"/>
-            <a:ext cx="9128455" cy="310896"/>
+            <a:off x="2011680" y="5495544"/>
+            <a:ext cx="9311335" cy="329184"/>
           </a:xfrm>
           <a:prstGeom prst="rect">
             <a:avLst/>
@@ -17951,13 +17957,13 @@
               </a:lnSpc>
             </a:pPr>
             <a:r>
-              <a:rPr sz="1100" b="0">
+              <a:rPr sz="1050" b="0">
                 <a:solidFill>
                   <a:srgbClr val="E7EDF4"/>
                 </a:solidFill>
                 <a:latin typeface="DM Sans"/>
               </a:rPr>
-              <a:t>10 % de la perte évitée, le plafond : le seul niveau où quelqu'un dit non à votre place quand tous vos signataires sont trompés · repère : Fireblocks, 999 $/mois</a:t>
+              <a:t>10 % de la perte évitée, le plafond : le seul niveau où quelqu'un dit non à votre place quand tous vos signataires sont trompés · repère : Fireblocks 999 $</a:t>
             </a:r>
           </a:p>
         </p:txBody>
@@ -17970,7 +17976,7 @@
         </p:nvSpPr>
         <p:spPr>
           <a:xfrm>
-            <a:off x="731520" y="5727288"/>
+            <a:off x="731520" y="5754720"/>
             <a:ext cx="10728655" cy="6000"/>
           </a:xfrm>
           <a:prstGeom prst="rect">
@@ -18014,8 +18020,8 @@
         </p:nvSpPr>
         <p:spPr>
           <a:xfrm>
-            <a:off x="731520" y="5797296"/>
-            <a:ext cx="1325880" cy="310896"/>
+            <a:off x="731520" y="5824728"/>
+            <a:ext cx="1143000" cy="329184"/>
           </a:xfrm>
           <a:prstGeom prst="rect">
             <a:avLst/>
@@ -18034,7 +18040,7 @@
               </a:lnSpc>
             </a:pPr>
             <a:r>
-              <a:rPr sz="1100" b="1">
+              <a:rPr sz="1050" b="1">
                 <a:solidFill>
                   <a:srgbClr val="F6F9FC"/>
                 </a:solidFill>
@@ -18053,8 +18059,8 @@
         </p:nvSpPr>
         <p:spPr>
           <a:xfrm>
-            <a:off x="2194560" y="5797296"/>
-            <a:ext cx="9128455" cy="310896"/>
+            <a:off x="2011680" y="5824728"/>
+            <a:ext cx="9311335" cy="329184"/>
           </a:xfrm>
           <a:prstGeom prst="rect">
             <a:avLst/>
@@ -18073,7 +18079,7 @@
               </a:lnSpc>
             </a:pPr>
             <a:r>
-              <a:rPr sz="1100" b="0">
+              <a:rPr sz="1050" b="0">
                 <a:solidFill>
                   <a:srgbClr val="E7EDF4"/>
                 </a:solidFill>
@@ -18092,7 +18098,7 @@
         </p:nvSpPr>
         <p:spPr>
           <a:xfrm>
-            <a:off x="731520" y="6038184"/>
+            <a:off x="731520" y="6083904"/>
             <a:ext cx="10728655" cy="6000"/>
           </a:xfrm>
           <a:prstGeom prst="rect">

</xml_diff>